<commit_message>
feat: update SQL scripts for news source integration and error handling
- Added a new network rule for Dow Jones feeds in the ingest script to enhance data sourcing capabilities.
- Updated RSS feed URLs for GlobeNewswire and MarketWatch to ensure accurate content retrieval.
- Improved error handling in the RSS news ingestion process to manage content type validation and parsing errors effectively.
- Refined scheduling logic in the news context refresh script to accommodate additional valid time slots for processing.
</commit_message>
<xml_diff>
--- a/docs/MIP how does it work.pptx
+++ b/docs/MIP how does it work.pptx
@@ -5,7 +5,7 @@
     <p:sldMasterId id="2147483648" r:id="rId1"/>
   </p:sldMasterIdLst>
   <p:notesMasterIdLst>
-    <p:notesMasterId r:id="rId27"/>
+    <p:notesMasterId r:id="rId24"/>
   </p:notesMasterIdLst>
   <p:sldIdLst>
     <p:sldId id="283" r:id="rId2"/>
@@ -30,9 +30,6 @@
     <p:sldId id="280" r:id="rId21"/>
     <p:sldId id="281" r:id="rId22"/>
     <p:sldId id="282" r:id="rId23"/>
-    <p:sldId id="274" r:id="rId24"/>
-    <p:sldId id="277" r:id="rId25"/>
-    <p:sldId id="270" r:id="rId26"/>
   </p:sldIdLst>
   <p:sldSz cx="12192000" cy="6858000"/>
   <p:notesSz cx="6858000" cy="9144000"/>
@@ -163,7 +160,7 @@
   <pc:docChgLst>
     <pc:chgData name="Kenneth Jebjerg" userId="31b26a954995a5e4" providerId="LiveId" clId="{FB9E2242-EB45-4C40-9CD8-7B1EDA37FE0A}"/>
     <pc:docChg chg="undo custSel addSld delSld modSld sldOrd">
-      <pc:chgData name="Kenneth Jebjerg" userId="31b26a954995a5e4" providerId="LiveId" clId="{FB9E2242-EB45-4C40-9CD8-7B1EDA37FE0A}" dt="2026-03-20T09:09:08.630" v="130" actId="12"/>
+      <pc:chgData name="Kenneth Jebjerg" userId="31b26a954995a5e4" providerId="LiveId" clId="{FB9E2242-EB45-4C40-9CD8-7B1EDA37FE0A}" dt="2026-03-20T10:20:55.555" v="348" actId="6549"/>
       <pc:docMkLst>
         <pc:docMk/>
       </pc:docMkLst>
@@ -357,6 +354,13 @@
           </ac:spMkLst>
         </pc:spChg>
       </pc:sldChg>
+      <pc:sldChg chg="del">
+        <pc:chgData name="Kenneth Jebjerg" userId="31b26a954995a5e4" providerId="LiveId" clId="{FB9E2242-EB45-4C40-9CD8-7B1EDA37FE0A}" dt="2026-03-20T10:13:15.135" v="131" actId="47"/>
+        <pc:sldMkLst>
+          <pc:docMk/>
+          <pc:sldMk cId="0" sldId="270"/>
+        </pc:sldMkLst>
+      </pc:sldChg>
       <pc:sldChg chg="add setBg">
         <pc:chgData name="Kenneth Jebjerg" userId="31b26a954995a5e4" providerId="LiveId" clId="{FB9E2242-EB45-4C40-9CD8-7B1EDA37FE0A}" dt="2026-03-20T08:37:03.007" v="8"/>
         <pc:sldMkLst>
@@ -372,7 +376,7 @@
         </pc:sldMkLst>
       </pc:sldChg>
       <pc:sldChg chg="add del setBg">
-        <pc:chgData name="Kenneth Jebjerg" userId="31b26a954995a5e4" providerId="LiveId" clId="{FB9E2242-EB45-4C40-9CD8-7B1EDA37FE0A}" dt="2026-03-20T08:47:53.026" v="33"/>
+        <pc:chgData name="Kenneth Jebjerg" userId="31b26a954995a5e4" providerId="LiveId" clId="{FB9E2242-EB45-4C40-9CD8-7B1EDA37FE0A}" dt="2026-03-20T10:13:15.135" v="131" actId="47"/>
         <pc:sldMkLst>
           <pc:docMk/>
           <pc:sldMk cId="0" sldId="274"/>
@@ -392,8 +396,8 @@
           <pc:sldMk cId="0" sldId="276"/>
         </pc:sldMkLst>
       </pc:sldChg>
-      <pc:sldChg chg="add setBg">
-        <pc:chgData name="Kenneth Jebjerg" userId="31b26a954995a5e4" providerId="LiveId" clId="{FB9E2242-EB45-4C40-9CD8-7B1EDA37FE0A}" dt="2026-03-20T08:43:52.908" v="29"/>
+      <pc:sldChg chg="add del setBg">
+        <pc:chgData name="Kenneth Jebjerg" userId="31b26a954995a5e4" providerId="LiveId" clId="{FB9E2242-EB45-4C40-9CD8-7B1EDA37FE0A}" dt="2026-03-20T10:13:15.135" v="131" actId="47"/>
         <pc:sldMkLst>
           <pc:docMk/>
           <pc:sldMk cId="0" sldId="277"/>
@@ -406,26 +410,178 @@
           <pc:sldMk cId="0" sldId="278"/>
         </pc:sldMkLst>
       </pc:sldChg>
-      <pc:sldChg chg="add setBg">
-        <pc:chgData name="Kenneth Jebjerg" userId="31b26a954995a5e4" providerId="LiveId" clId="{FB9E2242-EB45-4C40-9CD8-7B1EDA37FE0A}" dt="2026-03-20T08:47:53.026" v="33"/>
+      <pc:sldChg chg="modSp add mod setBg">
+        <pc:chgData name="Kenneth Jebjerg" userId="31b26a954995a5e4" providerId="LiveId" clId="{FB9E2242-EB45-4C40-9CD8-7B1EDA37FE0A}" dt="2026-03-20T10:20:55.555" v="348" actId="6549"/>
         <pc:sldMkLst>
           <pc:docMk/>
           <pc:sldMk cId="0" sldId="279"/>
         </pc:sldMkLst>
+        <pc:spChg chg="mod">
+          <ac:chgData name="Kenneth Jebjerg" userId="31b26a954995a5e4" providerId="LiveId" clId="{FB9E2242-EB45-4C40-9CD8-7B1EDA37FE0A}" dt="2026-03-20T10:20:10.146" v="318" actId="6549"/>
+          <ac:spMkLst>
+            <pc:docMk/>
+            <pc:sldMk cId="0" sldId="279"/>
+            <ac:spMk id="7" creationId="{00000000-0000-0000-0000-000000000000}"/>
+          </ac:spMkLst>
+        </pc:spChg>
+        <pc:spChg chg="mod">
+          <ac:chgData name="Kenneth Jebjerg" userId="31b26a954995a5e4" providerId="LiveId" clId="{FB9E2242-EB45-4C40-9CD8-7B1EDA37FE0A}" dt="2026-03-20T10:20:26.740" v="328" actId="6549"/>
+          <ac:spMkLst>
+            <pc:docMk/>
+            <pc:sldMk cId="0" sldId="279"/>
+            <ac:spMk id="9" creationId="{00000000-0000-0000-0000-000000000000}"/>
+          </ac:spMkLst>
+        </pc:spChg>
+        <pc:spChg chg="mod">
+          <ac:chgData name="Kenneth Jebjerg" userId="31b26a954995a5e4" providerId="LiveId" clId="{FB9E2242-EB45-4C40-9CD8-7B1EDA37FE0A}" dt="2026-03-20T10:20:40.827" v="338" actId="6549"/>
+          <ac:spMkLst>
+            <pc:docMk/>
+            <pc:sldMk cId="0" sldId="279"/>
+            <ac:spMk id="11" creationId="{00000000-0000-0000-0000-000000000000}"/>
+          </ac:spMkLst>
+        </pc:spChg>
+        <pc:spChg chg="mod">
+          <ac:chgData name="Kenneth Jebjerg" userId="31b26a954995a5e4" providerId="LiveId" clId="{FB9E2242-EB45-4C40-9CD8-7B1EDA37FE0A}" dt="2026-03-20T10:20:55.555" v="348" actId="6549"/>
+          <ac:spMkLst>
+            <pc:docMk/>
+            <pc:sldMk cId="0" sldId="279"/>
+            <ac:spMk id="13" creationId="{00000000-0000-0000-0000-000000000000}"/>
+          </ac:spMkLst>
+        </pc:spChg>
       </pc:sldChg>
-      <pc:sldChg chg="add setBg">
-        <pc:chgData name="Kenneth Jebjerg" userId="31b26a954995a5e4" providerId="LiveId" clId="{FB9E2242-EB45-4C40-9CD8-7B1EDA37FE0A}" dt="2026-03-20T08:47:53.026" v="33"/>
+      <pc:sldChg chg="modSp add mod setBg">
+        <pc:chgData name="Kenneth Jebjerg" userId="31b26a954995a5e4" providerId="LiveId" clId="{FB9E2242-EB45-4C40-9CD8-7B1EDA37FE0A}" dt="2026-03-20T10:18:07.888" v="308" actId="14100"/>
         <pc:sldMkLst>
           <pc:docMk/>
           <pc:sldMk cId="0" sldId="280"/>
         </pc:sldMkLst>
+        <pc:spChg chg="mod">
+          <ac:chgData name="Kenneth Jebjerg" userId="31b26a954995a5e4" providerId="LiveId" clId="{FB9E2242-EB45-4C40-9CD8-7B1EDA37FE0A}" dt="2026-03-20T10:17:24.396" v="265" actId="14100"/>
+          <ac:spMkLst>
+            <pc:docMk/>
+            <pc:sldMk cId="0" sldId="280"/>
+            <ac:spMk id="7" creationId="{00000000-0000-0000-0000-000000000000}"/>
+          </ac:spMkLst>
+        </pc:spChg>
+        <pc:spChg chg="mod">
+          <ac:chgData name="Kenneth Jebjerg" userId="31b26a954995a5e4" providerId="LiveId" clId="{FB9E2242-EB45-4C40-9CD8-7B1EDA37FE0A}" dt="2026-03-20T10:17:20.507" v="264" actId="14100"/>
+          <ac:spMkLst>
+            <pc:docMk/>
+            <pc:sldMk cId="0" sldId="280"/>
+            <ac:spMk id="9" creationId="{00000000-0000-0000-0000-000000000000}"/>
+          </ac:spMkLst>
+        </pc:spChg>
+        <pc:spChg chg="mod">
+          <ac:chgData name="Kenneth Jebjerg" userId="31b26a954995a5e4" providerId="LiveId" clId="{FB9E2242-EB45-4C40-9CD8-7B1EDA37FE0A}" dt="2026-03-20T10:17:30.847" v="266" actId="14100"/>
+          <ac:spMkLst>
+            <pc:docMk/>
+            <pc:sldMk cId="0" sldId="280"/>
+            <ac:spMk id="11" creationId="{00000000-0000-0000-0000-000000000000}"/>
+          </ac:spMkLst>
+        </pc:spChg>
+        <pc:spChg chg="mod">
+          <ac:chgData name="Kenneth Jebjerg" userId="31b26a954995a5e4" providerId="LiveId" clId="{FB9E2242-EB45-4C40-9CD8-7B1EDA37FE0A}" dt="2026-03-20T10:17:30.847" v="266" actId="14100"/>
+          <ac:spMkLst>
+            <pc:docMk/>
+            <pc:sldMk cId="0" sldId="280"/>
+            <ac:spMk id="13" creationId="{00000000-0000-0000-0000-000000000000}"/>
+          </ac:spMkLst>
+        </pc:spChg>
+        <pc:spChg chg="mod">
+          <ac:chgData name="Kenneth Jebjerg" userId="31b26a954995a5e4" providerId="LiveId" clId="{FB9E2242-EB45-4C40-9CD8-7B1EDA37FE0A}" dt="2026-03-20T10:17:43.094" v="305" actId="1038"/>
+          <ac:spMkLst>
+            <pc:docMk/>
+            <pc:sldMk cId="0" sldId="280"/>
+            <ac:spMk id="15" creationId="{00000000-0000-0000-0000-000000000000}"/>
+          </ac:spMkLst>
+        </pc:spChg>
+        <pc:spChg chg="mod">
+          <ac:chgData name="Kenneth Jebjerg" userId="31b26a954995a5e4" providerId="LiveId" clId="{FB9E2242-EB45-4C40-9CD8-7B1EDA37FE0A}" dt="2026-03-20T10:17:43.094" v="305" actId="1038"/>
+          <ac:spMkLst>
+            <pc:docMk/>
+            <pc:sldMk cId="0" sldId="280"/>
+            <ac:spMk id="16" creationId="{00000000-0000-0000-0000-000000000000}"/>
+          </ac:spMkLst>
+        </pc:spChg>
+        <pc:spChg chg="mod">
+          <ac:chgData name="Kenneth Jebjerg" userId="31b26a954995a5e4" providerId="LiveId" clId="{FB9E2242-EB45-4C40-9CD8-7B1EDA37FE0A}" dt="2026-03-20T10:17:43.094" v="305" actId="1038"/>
+          <ac:spMkLst>
+            <pc:docMk/>
+            <pc:sldMk cId="0" sldId="280"/>
+            <ac:spMk id="17" creationId="{00000000-0000-0000-0000-000000000000}"/>
+          </ac:spMkLst>
+        </pc:spChg>
+        <pc:spChg chg="mod">
+          <ac:chgData name="Kenneth Jebjerg" userId="31b26a954995a5e4" providerId="LiveId" clId="{FB9E2242-EB45-4C40-9CD8-7B1EDA37FE0A}" dt="2026-03-20T10:18:07.888" v="308" actId="14100"/>
+          <ac:spMkLst>
+            <pc:docMk/>
+            <pc:sldMk cId="0" sldId="280"/>
+            <ac:spMk id="18" creationId="{00000000-0000-0000-0000-000000000000}"/>
+          </ac:spMkLst>
+        </pc:spChg>
       </pc:sldChg>
-      <pc:sldChg chg="add setBg">
-        <pc:chgData name="Kenneth Jebjerg" userId="31b26a954995a5e4" providerId="LiveId" clId="{FB9E2242-EB45-4C40-9CD8-7B1EDA37FE0A}" dt="2026-03-20T08:47:53.026" v="33"/>
+      <pc:sldChg chg="modSp add mod setBg">
+        <pc:chgData name="Kenneth Jebjerg" userId="31b26a954995a5e4" providerId="LiveId" clId="{FB9E2242-EB45-4C40-9CD8-7B1EDA37FE0A}" dt="2026-03-20T10:15:41.913" v="257" actId="14100"/>
         <pc:sldMkLst>
           <pc:docMk/>
           <pc:sldMk cId="0" sldId="281"/>
         </pc:sldMkLst>
+        <pc:spChg chg="mod">
+          <ac:chgData name="Kenneth Jebjerg" userId="31b26a954995a5e4" providerId="LiveId" clId="{FB9E2242-EB45-4C40-9CD8-7B1EDA37FE0A}" dt="2026-03-20T10:15:41.913" v="257" actId="14100"/>
+          <ac:spMkLst>
+            <pc:docMk/>
+            <pc:sldMk cId="0" sldId="281"/>
+            <ac:spMk id="7" creationId="{00000000-0000-0000-0000-000000000000}"/>
+          </ac:spMkLst>
+        </pc:spChg>
+        <pc:spChg chg="mod">
+          <ac:chgData name="Kenneth Jebjerg" userId="31b26a954995a5e4" providerId="LiveId" clId="{FB9E2242-EB45-4C40-9CD8-7B1EDA37FE0A}" dt="2026-03-20T10:15:05.435" v="193" actId="1035"/>
+          <ac:spMkLst>
+            <pc:docMk/>
+            <pc:sldMk cId="0" sldId="281"/>
+            <ac:spMk id="32" creationId="{00000000-0000-0000-0000-000000000000}"/>
+          </ac:spMkLst>
+        </pc:spChg>
+        <pc:spChg chg="mod">
+          <ac:chgData name="Kenneth Jebjerg" userId="31b26a954995a5e4" providerId="LiveId" clId="{FB9E2242-EB45-4C40-9CD8-7B1EDA37FE0A}" dt="2026-03-20T10:14:56.414" v="170" actId="1036"/>
+          <ac:spMkLst>
+            <pc:docMk/>
+            <pc:sldMk cId="0" sldId="281"/>
+            <ac:spMk id="33" creationId="{00000000-0000-0000-0000-000000000000}"/>
+          </ac:spMkLst>
+        </pc:spChg>
+        <pc:spChg chg="mod">
+          <ac:chgData name="Kenneth Jebjerg" userId="31b26a954995a5e4" providerId="LiveId" clId="{FB9E2242-EB45-4C40-9CD8-7B1EDA37FE0A}" dt="2026-03-20T10:14:51.674" v="156" actId="1036"/>
+          <ac:spMkLst>
+            <pc:docMk/>
+            <pc:sldMk cId="0" sldId="281"/>
+            <ac:spMk id="34" creationId="{00000000-0000-0000-0000-000000000000}"/>
+          </ac:spMkLst>
+        </pc:spChg>
+        <pc:spChg chg="mod">
+          <ac:chgData name="Kenneth Jebjerg" userId="31b26a954995a5e4" providerId="LiveId" clId="{FB9E2242-EB45-4C40-9CD8-7B1EDA37FE0A}" dt="2026-03-20T10:15:28.761" v="256" actId="1035"/>
+          <ac:spMkLst>
+            <pc:docMk/>
+            <pc:sldMk cId="0" sldId="281"/>
+            <ac:spMk id="35" creationId="{00000000-0000-0000-0000-000000000000}"/>
+          </ac:spMkLst>
+        </pc:spChg>
+        <pc:spChg chg="mod">
+          <ac:chgData name="Kenneth Jebjerg" userId="31b26a954995a5e4" providerId="LiveId" clId="{FB9E2242-EB45-4C40-9CD8-7B1EDA37FE0A}" dt="2026-03-20T10:15:28.761" v="256" actId="1035"/>
+          <ac:spMkLst>
+            <pc:docMk/>
+            <pc:sldMk cId="0" sldId="281"/>
+            <ac:spMk id="36" creationId="{00000000-0000-0000-0000-000000000000}"/>
+          </ac:spMkLst>
+        </pc:spChg>
+        <pc:spChg chg="mod">
+          <ac:chgData name="Kenneth Jebjerg" userId="31b26a954995a5e4" providerId="LiveId" clId="{FB9E2242-EB45-4C40-9CD8-7B1EDA37FE0A}" dt="2026-03-20T10:15:11.051" v="205" actId="1036"/>
+          <ac:spMkLst>
+            <pc:docMk/>
+            <pc:sldMk cId="0" sldId="281"/>
+            <ac:spMk id="37" creationId="{00000000-0000-0000-0000-000000000000}"/>
+          </ac:spMkLst>
+        </pc:spChg>
       </pc:sldChg>
       <pc:sldChg chg="add setBg">
         <pc:chgData name="Kenneth Jebjerg" userId="31b26a954995a5e4" providerId="LiveId" clId="{FB9E2242-EB45-4C40-9CD8-7B1EDA37FE0A}" dt="2026-03-20T08:47:53.026" v="33"/>
@@ -812,224 +968,6 @@
 </p:notesMaster>
 </file>
 
-<file path=ppt/notesSlides/notesSlide1.xml><?xml version="1.0" encoding="utf-8"?>
-<p:notes xmlns:a="http://schemas.openxmlformats.org/drawingml/2006/main" xmlns:r="http://schemas.openxmlformats.org/officeDocument/2006/relationships" xmlns:p="http://schemas.openxmlformats.org/presentationml/2006/main">
-  <p:cSld>
-    <p:spTree>
-      <p:nvGrpSpPr>
-        <p:cNvPr id="1" name=""/>
-        <p:cNvGrpSpPr/>
-        <p:nvPr/>
-      </p:nvGrpSpPr>
-      <p:grpSpPr>
-        <a:xfrm>
-          <a:off x="0" y="0"/>
-          <a:ext cx="0" cy="0"/>
-          <a:chOff x="0" y="0"/>
-          <a:chExt cx="0" cy="0"/>
-        </a:xfrm>
-      </p:grpSpPr>
-      <p:sp>
-        <p:nvSpPr>
-          <p:cNvPr id="2" name="Slide Image Placeholder 1"/>
-          <p:cNvSpPr>
-            <a:spLocks noGrp="1" noRot="1" noChangeAspect="1"/>
-          </p:cNvSpPr>
-          <p:nvPr>
-            <p:ph type="sldImg" idx="2"/>
-          </p:nvPr>
-        </p:nvSpPr>
-        <p:spPr/>
-      </p:sp>
-      <p:sp>
-        <p:nvSpPr>
-          <p:cNvPr id="3" name="Notes Placeholder 2"/>
-          <p:cNvSpPr>
-            <a:spLocks noGrp="1"/>
-          </p:cNvSpPr>
-          <p:nvPr>
-            <p:ph type="body" sz="quarter" idx="3"/>
-          </p:nvPr>
-        </p:nvSpPr>
-        <p:spPr/>
-        <p:txBody>
-          <a:bodyPr/>
-          <a:lstStyle/>
-          <a:p>
-            <a:r>
-              <a:t>SPEAKER NOTES — How MIP Was Built</a:t>
-            </a:r>
-          </a:p>
-          <a:p>
-            <a:endParaRPr/>
-          </a:p>
-          <a:p>
-            <a:r>
-              <a:t>This is the slide that usually gets the biggest reaction.</a:t>
-            </a:r>
-          </a:p>
-          <a:p>
-            <a:endParaRPr/>
-          </a:p>
-          <a:p>
-            <a:r>
-              <a:t>THE HEADLINE:</a:t>
-            </a:r>
-          </a:p>
-          <a:p>
-            <a:r>
-              <a:t>MIP is 65,700 lines of code across 299 files, spanning SQL, Python, JavaScript, and CSS. I have not typed a single line of code myself. Not one character. Every line was generated by AI agents that I directed.</a:t>
-            </a:r>
-          </a:p>
-          <a:p>
-            <a:endParaRPr/>
-          </a:p>
-          <a:p>
-            <a:r>
-              <a:t>THE DEVELOPMENT TIMELINE:</a:t>
-            </a:r>
-          </a:p>
-          <a:p>
-            <a:endParaRPr/>
-          </a:p>
-          <a:p>
-            <a:r>
-              <a:t>Phase 1 — OCTOBER TO DECEMBER 2025:</a:t>
-            </a:r>
-          </a:p>
-          <a:p>
-            <a:r>
-              <a:t>I started with ChatGPT as my investment domain expert and solution architect. I'd describe what I wanted — "I need a trust classification system that evaluates signals at multiple forward horizons" — and ChatGPT would help me think through the design, the data model, the edge cases. Then OpenAI Codex would generate the actual code: the stored procedures, the views, the tables.</a:t>
-            </a:r>
-          </a:p>
-          <a:p>
-            <a:endParaRPr/>
-          </a:p>
-          <a:p>
-            <a:r>
-              <a:t>My role was visionary and orchestrator. I knew what I wanted MIP to be, and I directed the AI to build it. I reviewed every output, made architectural decisions, and steered the direction.</a:t>
-            </a:r>
-          </a:p>
-          <a:p>
-            <a:endParaRPr/>
-          </a:p>
-          <a:p>
-            <a:r>
-              <a:t>Phase 2 — JANUARY 2026:</a:t>
-            </a:r>
-          </a:p>
-          <a:p>
-            <a:r>
-              <a:t>I switched to Cursor with Claude (Opus and Sonnet) as the primary development agent. This was a step change — Cursor understands the full codebase context, can read files, search code, and make targeted edits. I still used ChatGPT for bouncing ideas and producing detailed requirements, but Cursor became the developer.</a:t>
-            </a:r>
-          </a:p>
-          <a:p>
-            <a:endParaRPr/>
-          </a:p>
-          <a:p>
-            <a:r>
-              <a:t>Phase 3 — FEBRUARY 2026:</a:t>
-            </a:r>
-          </a:p>
-          <a:p>
-            <a:r>
-              <a:t>Full autonomy. Cursor now has direct access to Snowflake. It deploys stored procedures, runs smoke tests, diagnoses data issues, and repairs problems — all autonomously. I review the results and make product decisions, but the implementation is entirely AI-driven.</a:t>
-            </a:r>
-          </a:p>
-          <a:p>
-            <a:endParaRPr/>
-          </a:p>
-          <a:p>
-            <a:r>
-              <a:t>THE ROLES:</a:t>
-            </a:r>
-          </a:p>
-          <a:p>
-            <a:r>
-              <a:t>- VISIONARY: I conceived MIP's mission — "signals should earn trust through data." I defined the five-level autonomy roadmap. I decided what features to build and in what order.</a:t>
-            </a:r>
-          </a:p>
-          <a:p>
-            <a:r>
-              <a:t>- ORCHESTRATOR: I directed the AI agents. When ChatGPT proposed an architecture, I'd challenge it, refine it, or redirect. When Cursor implemented something, I'd review and steer.</a:t>
-            </a:r>
-          </a:p>
-          <a:p>
-            <a:r>
-              <a:t>- PRODUCT OWNER: I prioritised features, defined acceptance criteria, and decided when something was "done." The AI built what I asked for, but I decided what to ask for.</a:t>
-            </a:r>
-          </a:p>
-          <a:p>
-            <a:endParaRPr/>
-          </a:p>
-          <a:p>
-            <a:r>
-              <a:t>THE NUMBERS (walk through the table):</a:t>
-            </a:r>
-          </a:p>
-          <a:p>
-            <a:r>
-              <a:t>- SQL dominates at 41% — reflects the "all logic in Snowflake" philosophy</a:t>
-            </a:r>
-          </a:p>
-          <a:p>
-            <a:r>
-              <a:t>- React frontend is substantial at 33% — 7 screens with full styling</a:t>
-            </a:r>
-          </a:p>
-          <a:p>
-            <a:r>
-              <a:t>- Python API is deliberately thin at 13% — just data delivery</a:t>
-            </a:r>
-          </a:p>
-          <a:p>
-            <a:r>
-              <a:t>- Documentation at 7% — 35 markdown files covering architecture, guides, runbooks</a:t>
-            </a:r>
-          </a:p>
-          <a:p>
-            <a:endParaRPr/>
-          </a:p>
-          <a:p>
-            <a:r>
-              <a:t>THE KEY INSIGHT:</a:t>
-            </a:r>
-          </a:p>
-          <a:p>
-            <a:r>
-              <a:t>How often do you see a system with 65,000+ lines of production-quality code that was built entirely by AI agents, directed by a single person who never wrote a line? This isn't a demo or a proof of concept. It runs daily, handles edge cases, has comprehensive error handling, and serves a real analytical purpose.</a:t>
-            </a:r>
-          </a:p>
-          <a:p>
-            <a:endParaRPr/>
-          </a:p>
-          <a:p>
-            <a:r>
-              <a:t>The AI wrote the code. I made the decisions. That division of labour — human judgment plus AI execution — is exactly what the future of software development looks like.</a:t>
-            </a:r>
-          </a:p>
-        </p:txBody>
-      </p:sp>
-      <p:sp>
-        <p:nvSpPr>
-          <p:cNvPr id="4" name="Slide Number Placeholder 3"/>
-          <p:cNvSpPr>
-            <a:spLocks noGrp="1"/>
-          </p:cNvSpPr>
-          <p:nvPr>
-            <p:ph type="sldNum" sz="quarter" idx="5"/>
-          </p:nvPr>
-        </p:nvSpPr>
-        <p:spPr/>
-      </p:sp>
-    </p:spTree>
-  </p:cSld>
-  <p:clrMapOvr>
-    <a:masterClrMapping/>
-  </p:clrMapOvr>
-</p:notes>
-</file>
-
 <file path=ppt/slideLayouts/slideLayout1.xml><?xml version="1.0" encoding="utf-8"?>
 <p:sldLayout xmlns:a="http://schemas.openxmlformats.org/drawingml/2006/main" xmlns:r="http://schemas.openxmlformats.org/officeDocument/2006/relationships" xmlns:p="http://schemas.openxmlformats.org/presentationml/2006/main" type="title" preserve="1">
   <p:cSld name="Title Slide">
@@ -17293,6 +17231,7 @@
               </a:defRPr>
             </a:pPr>
             <a:r>
+              <a:rPr dirty="0"/>
               <a:t>Database &amp; AI</a:t>
             </a:r>
           </a:p>
@@ -17308,7 +17247,8 @@
               </a:defRPr>
             </a:pPr>
             <a:r>
-              <a:t>  Snowflake  —  Data warehouse, compute, and orchestration</a:t>
+              <a:rPr dirty="0"/>
+              <a:t>Snowflake  —  Data warehouse, compute, and orchestration</a:t>
             </a:r>
           </a:p>
           <a:p>
@@ -17323,7 +17263,8 @@
               </a:defRPr>
             </a:pPr>
             <a:r>
-              <a:t>  Snowflake Cortex  —  Native LLM inference (Claude, Mistral)</a:t>
+              <a:rPr dirty="0"/>
+              <a:t>Snowflake Cortex  —  Native LLM inference (Claude, Mistral)</a:t>
             </a:r>
           </a:p>
           <a:p>
@@ -17338,7 +17279,8 @@
               </a:defRPr>
             </a:pPr>
             <a:r>
-              <a:t>  Stored Procedures  —  60+ business logic procedures</a:t>
+              <a:rPr dirty="0"/>
+              <a:t>Stored Procedures  —  60+ business logic procedures</a:t>
             </a:r>
           </a:p>
           <a:p>
@@ -17353,7 +17295,8 @@
               </a:defRPr>
             </a:pPr>
             <a:r>
-              <a:t>  Scheduled Tasks  —  Daily, hourly, and intraday pipelines</a:t>
+              <a:rPr dirty="0"/>
+              <a:t>Scheduled Tasks  —  Daily, hourly, and intraday pipelines</a:t>
             </a:r>
           </a:p>
           <a:p>
@@ -17368,7 +17311,8 @@
               </a:defRPr>
             </a:pPr>
             <a:r>
-              <a:t>  External Access  —  Network rules for market data APIs</a:t>
+              <a:rPr dirty="0"/>
+              <a:t>External Access  —  Network rules for market data APIs</a:t>
             </a:r>
           </a:p>
         </p:txBody>
@@ -17467,6 +17411,7 @@
               </a:defRPr>
             </a:pPr>
             <a:r>
+              <a:rPr dirty="0"/>
               <a:t>Backend API</a:t>
             </a:r>
           </a:p>
@@ -17482,7 +17427,8 @@
               </a:defRPr>
             </a:pPr>
             <a:r>
-              <a:t>  Python 3.12  —  Runtime for API and scripts</a:t>
+              <a:rPr dirty="0"/>
+              <a:t>Python 3.12  —  Runtime for API and scripts</a:t>
             </a:r>
           </a:p>
           <a:p>
@@ -17497,7 +17443,12 @@
               </a:defRPr>
             </a:pPr>
             <a:r>
-              <a:t>  FastAPI  —  High-performance async REST framework</a:t>
+              <a:rPr dirty="0" err="1"/>
+              <a:t>FastAPI</a:t>
+            </a:r>
+            <a:r>
+              <a:rPr dirty="0"/>
+              <a:t>  —  High-performance async REST framework</a:t>
             </a:r>
           </a:p>
           <a:p>
@@ -17512,7 +17463,12 @@
               </a:defRPr>
             </a:pPr>
             <a:r>
-              <a:t>  Uvicorn  —  ASGI server for production</a:t>
+              <a:rPr dirty="0" err="1"/>
+              <a:t>Uvicorn</a:t>
+            </a:r>
+            <a:r>
+              <a:rPr dirty="0"/>
+              <a:t>  —  ASGI server for production</a:t>
             </a:r>
           </a:p>
           <a:p>
@@ -17527,7 +17483,8 @@
               </a:defRPr>
             </a:pPr>
             <a:r>
-              <a:t>  snowflake-connector-python  —  Native DB driver</a:t>
+              <a:rPr dirty="0"/>
+              <a:t>snowflake-connector-python  —  Native DB driver</a:t>
             </a:r>
           </a:p>
           <a:p>
@@ -17542,7 +17499,12 @@
               </a:defRPr>
             </a:pPr>
             <a:r>
-              <a:t>  ib-insync  —  Interactive Brokers integration</a:t>
+              <a:rPr dirty="0" err="1"/>
+              <a:t>ib-insync</a:t>
+            </a:r>
+            <a:r>
+              <a:rPr dirty="0"/>
+              <a:t>  —  Interactive Brokers integration</a:t>
             </a:r>
           </a:p>
         </p:txBody>
@@ -17641,6 +17603,7 @@
               </a:defRPr>
             </a:pPr>
             <a:r>
+              <a:rPr dirty="0"/>
               <a:t>Frontend</a:t>
             </a:r>
           </a:p>
@@ -17656,7 +17619,8 @@
               </a:defRPr>
             </a:pPr>
             <a:r>
-              <a:t>  React 18  —  Component-based UI framework</a:t>
+              <a:rPr dirty="0"/>
+              <a:t>React 18  —  Component-based UI framework</a:t>
             </a:r>
           </a:p>
           <a:p>
@@ -17671,7 +17635,8 @@
               </a:defRPr>
             </a:pPr>
             <a:r>
-              <a:t>  Vite 5  —  Lightning-fast build and dev server</a:t>
+              <a:rPr dirty="0"/>
+              <a:t>Vite 5  —  Lightning-fast build and dev server</a:t>
             </a:r>
           </a:p>
           <a:p>
@@ -17686,7 +17651,8 @@
               </a:defRPr>
             </a:pPr>
             <a:r>
-              <a:t>  Plotly.js + Recharts  —  Interactive financial charts</a:t>
+              <a:rPr dirty="0"/>
+              <a:t>Plotly.js + Recharts  —  Interactive financial charts</a:t>
             </a:r>
           </a:p>
           <a:p>
@@ -17701,7 +17667,8 @@
               </a:defRPr>
             </a:pPr>
             <a:r>
-              <a:t>  React Router 6  —  Client-side navigation</a:t>
+              <a:rPr dirty="0"/>
+              <a:t>React Router 6  —  Client-side navigation</a:t>
             </a:r>
           </a:p>
           <a:p>
@@ -17716,7 +17683,8 @@
               </a:defRPr>
             </a:pPr>
             <a:r>
-              <a:t>  react-markdown  —  AI narrative rendering</a:t>
+              <a:rPr dirty="0"/>
+              <a:t>react-markdown  —  AI narrative rendering</a:t>
             </a:r>
           </a:p>
         </p:txBody>
@@ -17815,6 +17783,7 @@
               </a:defRPr>
             </a:pPr>
             <a:r>
+              <a:rPr dirty="0"/>
               <a:t>Integrations</a:t>
             </a:r>
           </a:p>
@@ -17830,7 +17799,8 @@
               </a:defRPr>
             </a:pPr>
             <a:r>
-              <a:t>  Interactive Brokers  —  Live + paper trading</a:t>
+              <a:rPr dirty="0"/>
+              <a:t>Interactive Brokers  —  Live + paper trading</a:t>
             </a:r>
           </a:p>
           <a:p>
@@ -17845,7 +17815,12 @@
               </a:defRPr>
             </a:pPr>
             <a:r>
-              <a:t>  AlphaVantage  —  Historical OHLCV market data</a:t>
+              <a:rPr dirty="0" err="1"/>
+              <a:t>AlphaVantage</a:t>
+            </a:r>
+            <a:r>
+              <a:rPr dirty="0"/>
+              <a:t>  —  Historical OHLCV market data</a:t>
             </a:r>
           </a:p>
           <a:p>
@@ -17860,7 +17835,8 @@
               </a:defRPr>
             </a:pPr>
             <a:r>
-              <a:t>  RSS Feeds  —  SEC, Fed, ECB, MarketWatch, IBKR</a:t>
+              <a:rPr dirty="0"/>
+              <a:t>RSS Feeds  —  SEC, Fed, ECB, MarketWatch, IBKR</a:t>
             </a:r>
           </a:p>
           <a:p>
@@ -17875,7 +17851,8 @@
               </a:defRPr>
             </a:pPr>
             <a:r>
-              <a:t>  GitHub Actions  —  CI/CD pipeline</a:t>
+              <a:rPr dirty="0"/>
+              <a:t>GitHub Actions  —  CI/CD pipeline</a:t>
             </a:r>
           </a:p>
           <a:p>
@@ -17890,7 +17867,8 @@
               </a:defRPr>
             </a:pPr>
             <a:r>
-              <a:t>  Cursor (Claude)  —  AI-assisted development</a:t>
+              <a:rPr dirty="0"/>
+              <a:t>Cursor (Claude)  —  AI-assisted development</a:t>
             </a:r>
           </a:p>
         </p:txBody>
@@ -19714,7 +19692,7 @@
         <p:spPr>
           <a:xfrm>
             <a:off x="640080" y="1874519"/>
-            <a:ext cx="10881360" cy="960120"/>
+            <a:ext cx="7737004" cy="960120"/>
           </a:xfrm>
           <a:prstGeom prst="roundRect">
             <a:avLst/>
@@ -19842,7 +19820,7 @@
         <p:spPr>
           <a:xfrm>
             <a:off x="640080" y="2971800"/>
-            <a:ext cx="10881360" cy="960120"/>
+            <a:ext cx="7737004" cy="960120"/>
           </a:xfrm>
           <a:prstGeom prst="roundRect">
             <a:avLst/>
@@ -19970,7 +19948,7 @@
         <p:spPr>
           <a:xfrm>
             <a:off x="640080" y="4069080"/>
-            <a:ext cx="10881360" cy="960120"/>
+            <a:ext cx="7737004" cy="960120"/>
           </a:xfrm>
           <a:prstGeom prst="roundRect">
             <a:avLst/>
@@ -20098,7 +20076,7 @@
         <p:spPr>
           <a:xfrm>
             <a:off x="640080" y="5166360"/>
-            <a:ext cx="10881360" cy="960120"/>
+            <a:ext cx="7737004" cy="960120"/>
           </a:xfrm>
           <a:prstGeom prst="roundRect">
             <a:avLst/>
@@ -20225,7 +20203,7 @@
         </p:nvSpPr>
         <p:spPr>
           <a:xfrm>
-            <a:off x="5852160" y="2852928"/>
+            <a:off x="4190504" y="2852928"/>
             <a:ext cx="457200" cy="109728"/>
           </a:xfrm>
           <a:prstGeom prst="downArrow">
@@ -20269,7 +20247,7 @@
         </p:nvSpPr>
         <p:spPr>
           <a:xfrm>
-            <a:off x="5852160" y="3950208"/>
+            <a:off x="4190504" y="3950208"/>
             <a:ext cx="457200" cy="109728"/>
           </a:xfrm>
           <a:prstGeom prst="downArrow">
@@ -20313,7 +20291,7 @@
         </p:nvSpPr>
         <p:spPr>
           <a:xfrm>
-            <a:off x="5852160" y="5047488"/>
+            <a:off x="4190504" y="5047488"/>
             <a:ext cx="457200" cy="109728"/>
           </a:xfrm>
           <a:prstGeom prst="downArrow">
@@ -20357,8 +20335,8 @@
         </p:nvSpPr>
         <p:spPr>
           <a:xfrm>
-            <a:off x="7772400" y="1874519"/>
-            <a:ext cx="3749039" cy="2743200"/>
+            <a:off x="8888361" y="1882286"/>
+            <a:ext cx="3113876" cy="4289914"/>
           </a:xfrm>
           <a:prstGeom prst="roundRect">
             <a:avLst/>
@@ -20398,6 +20376,7 @@
               </a:defRPr>
             </a:pPr>
             <a:r>
+              <a:rPr dirty="0"/>
               <a:t>EXTERNAL SYSTEMS</a:t>
             </a:r>
           </a:p>
@@ -20413,6 +20392,7 @@
               </a:defRPr>
             </a:pPr>
             <a:r>
+              <a:rPr dirty="0"/>
               <a:t>  Interactive Brokers (IBKR)</a:t>
             </a:r>
           </a:p>
@@ -20428,6 +20408,7 @@
               </a:defRPr>
             </a:pPr>
             <a:r>
+              <a:rPr dirty="0"/>
               <a:t>    Paper + Live trading accounts</a:t>
             </a:r>
           </a:p>
@@ -20443,6 +20424,7 @@
               </a:defRPr>
             </a:pPr>
             <a:r>
+              <a:rPr dirty="0"/>
               <a:t>    Order placement + snapshots</a:t>
             </a:r>
           </a:p>
@@ -20458,6 +20440,7 @@
               </a:defRPr>
             </a:pPr>
             <a:r>
+              <a:rPr dirty="0"/>
               <a:t>  </a:t>
             </a:r>
           </a:p>
@@ -20473,8 +20456,14 @@
               </a:defRPr>
             </a:pPr>
             <a:r>
-              <a:t>  AlphaVantage</a:t>
-            </a:r>
+              <a:rPr dirty="0"/>
+              <a:t>  </a:t>
+            </a:r>
+            <a:r>
+              <a:rPr dirty="0" err="1"/>
+              <a:t>AlphaVantage</a:t>
+            </a:r>
+            <a:endParaRPr dirty="0"/>
           </a:p>
           <a:p>
             <a:pPr>
@@ -20488,6 +20477,7 @@
               </a:defRPr>
             </a:pPr>
             <a:r>
+              <a:rPr dirty="0"/>
               <a:t>    Historical OHLCV bars</a:t>
             </a:r>
           </a:p>
@@ -20503,6 +20493,7 @@
               </a:defRPr>
             </a:pPr>
             <a:r>
+              <a:rPr dirty="0"/>
               <a:t>  </a:t>
             </a:r>
           </a:p>
@@ -20518,6 +20509,7 @@
               </a:defRPr>
             </a:pPr>
             <a:r>
+              <a:rPr dirty="0"/>
               <a:t>  RSS News Feeds</a:t>
             </a:r>
           </a:p>
@@ -20533,6 +20525,7 @@
               </a:defRPr>
             </a:pPr>
             <a:r>
+              <a:rPr dirty="0"/>
               <a:t>    SEC, Fed, ECB, MarketWatch</a:t>
             </a:r>
           </a:p>
@@ -20862,8 +20855,8 @@
         </p:nvSpPr>
         <p:spPr>
           <a:xfrm>
-            <a:off x="4572000" y="2834640"/>
-            <a:ext cx="3017520" cy="1097280"/>
+            <a:off x="4946903" y="1837945"/>
+            <a:ext cx="2267712" cy="2980943"/>
           </a:xfrm>
           <a:prstGeom prst="roundRect">
             <a:avLst/>
@@ -22200,7 +22193,7 @@
         </p:nvSpPr>
         <p:spPr>
           <a:xfrm>
-            <a:off x="457200" y="5029200"/>
+            <a:off x="457200" y="4783398"/>
             <a:ext cx="3931920" cy="274320"/>
           </a:xfrm>
           <a:prstGeom prst="rect">
@@ -22235,7 +22228,7 @@
         </p:nvSpPr>
         <p:spPr>
           <a:xfrm>
-            <a:off x="7772400" y="5029200"/>
+            <a:off x="7772400" y="4783392"/>
             <a:ext cx="3931920" cy="274320"/>
           </a:xfrm>
           <a:prstGeom prst="rect">
@@ -22257,6 +22250,7 @@
               </a:defRPr>
             </a:pPr>
             <a:r>
+              <a:rPr dirty="0"/>
               <a:t>PYTHON API  +  SQL PROCEDURES</a:t>
             </a:r>
           </a:p>
@@ -22270,7 +22264,7 @@
         </p:nvSpPr>
         <p:spPr>
           <a:xfrm>
-            <a:off x="457200" y="5394960"/>
+            <a:off x="457200" y="5680096"/>
             <a:ext cx="11247120" cy="640080"/>
           </a:xfrm>
           <a:prstGeom prst="roundRect">
@@ -22311,6 +22305,7 @@
               </a:defRPr>
             </a:pPr>
             <a:r>
+              <a:rPr dirty="0"/>
               <a:t>SAFETY NET  —  Every AI call has a deterministic fallback</a:t>
             </a:r>
           </a:p>
@@ -22326,6 +22321,7 @@
               </a:defRPr>
             </a:pPr>
             <a:r>
+              <a:rPr dirty="0"/>
               <a:t>    If Cortex fails or times out: digests generate bullet-point summaries from snapshots, committee falls back to deterministic approval, news uses heuristic extraction, and Ask MIP returns a service error.  No AI failure can halt the trading pipeline.</a:t>
             </a:r>
           </a:p>
@@ -22339,7 +22335,7 @@
         </p:nvSpPr>
         <p:spPr>
           <a:xfrm>
-            <a:off x="4572000" y="4114800"/>
+            <a:off x="4572000" y="4980037"/>
             <a:ext cx="3017520" cy="274320"/>
           </a:xfrm>
           <a:prstGeom prst="rect">
@@ -22361,6 +22357,7 @@
               </a:defRPr>
             </a:pPr>
             <a:r>
+              <a:rPr dirty="0"/>
               <a:t>Output → AGENT_OUT schema</a:t>
             </a:r>
           </a:p>
@@ -22374,7 +22371,7 @@
         </p:nvSpPr>
         <p:spPr>
           <a:xfrm>
-            <a:off x="5852160" y="3977639"/>
+            <a:off x="5852160" y="4842876"/>
             <a:ext cx="457200" cy="164592"/>
           </a:xfrm>
           <a:prstGeom prst="downArrow">
@@ -22418,7 +22415,7 @@
         </p:nvSpPr>
         <p:spPr>
           <a:xfrm>
-            <a:off x="3840480" y="4389120"/>
+            <a:off x="3901287" y="5126344"/>
             <a:ext cx="4389120" cy="548640"/>
           </a:xfrm>
           <a:prstGeom prst="rect">
@@ -22440,6 +22437,7 @@
               </a:defRPr>
             </a:pPr>
             <a:r>
+              <a:rPr dirty="0"/>
               <a:t>DAILY_DIGEST_NARRATIVE  •  TRAINING_DIGEST_NARRATIVE  •  PORTFOLIO_LIFECYCLE_NARRATIVE  •  PARALLEL_WORLD_NARRATIVE  •  ORDER_PROPOSALS  •  NEWS_EVENT_EXTRACTED  •  ASK_QUERY_EVENT</a:t>
             </a:r>
           </a:p>
@@ -25575,3979 +25573,6 @@
             </a:pPr>
             <a:r>
               <a:t>Each played to their strengths.  117,700 lines.  594 files.  6 months.  One human involved.”</a:t>
-            </a:r>
-          </a:p>
-        </p:txBody>
-      </p:sp>
-    </p:spTree>
-  </p:cSld>
-  <p:clrMapOvr>
-    <a:masterClrMapping/>
-  </p:clrMapOvr>
-</p:sld>
-</file>
-
-<file path=ppt/slides/slide23.xml><?xml version="1.0" encoding="utf-8"?>
-<p:sld xmlns:a="http://schemas.openxmlformats.org/drawingml/2006/main" xmlns:r="http://schemas.openxmlformats.org/officeDocument/2006/relationships" xmlns:p="http://schemas.openxmlformats.org/presentationml/2006/main">
-  <p:cSld>
-    <p:spTree>
-      <p:nvGrpSpPr>
-        <p:cNvPr id="1" name=""/>
-        <p:cNvGrpSpPr/>
-        <p:nvPr/>
-      </p:nvGrpSpPr>
-      <p:grpSpPr>
-        <a:xfrm>
-          <a:off x="0" y="0"/>
-          <a:ext cx="0" cy="0"/>
-          <a:chOff x="0" y="0"/>
-          <a:chExt cx="0" cy="0"/>
-        </a:xfrm>
-      </p:grpSpPr>
-      <p:sp>
-        <p:nvSpPr>
-          <p:cNvPr id="2" name="Rectangle 1"/>
-          <p:cNvSpPr/>
-          <p:nvPr/>
-        </p:nvSpPr>
-        <p:spPr>
-          <a:xfrm>
-            <a:off x="0" y="0"/>
-            <a:ext cx="12191695" cy="6858000"/>
-          </a:xfrm>
-          <a:prstGeom prst="rect">
-            <a:avLst/>
-          </a:prstGeom>
-          <a:solidFill>
-            <a:srgbClr val="0F172A"/>
-          </a:solidFill>
-          <a:ln>
-            <a:noFill/>
-          </a:ln>
-        </p:spPr>
-        <p:style>
-          <a:lnRef idx="1">
-            <a:schemeClr val="accent1"/>
-          </a:lnRef>
-          <a:fillRef idx="3">
-            <a:schemeClr val="accent1"/>
-          </a:fillRef>
-          <a:effectRef idx="2">
-            <a:schemeClr val="accent1"/>
-          </a:effectRef>
-          <a:fontRef idx="minor">
-            <a:schemeClr val="lt1"/>
-          </a:fontRef>
-        </p:style>
-        <p:txBody>
-          <a:bodyPr rtlCol="0" anchor="ctr"/>
-          <a:lstStyle/>
-          <a:p>
-            <a:pPr algn="ctr"/>
-            <a:endParaRPr/>
-          </a:p>
-        </p:txBody>
-      </p:sp>
-      <p:sp>
-        <p:nvSpPr>
-          <p:cNvPr id="3" name="Rectangle 2"/>
-          <p:cNvSpPr/>
-          <p:nvPr/>
-        </p:nvSpPr>
-        <p:spPr>
-          <a:xfrm>
-            <a:off x="822960" y="914400"/>
-            <a:ext cx="137160" cy="5029200"/>
-          </a:xfrm>
-          <a:prstGeom prst="rect">
-            <a:avLst/>
-          </a:prstGeom>
-          <a:solidFill>
-            <a:srgbClr val="3069F0"/>
-          </a:solidFill>
-          <a:ln>
-            <a:noFill/>
-          </a:ln>
-        </p:spPr>
-        <p:style>
-          <a:lnRef idx="1">
-            <a:schemeClr val="accent1"/>
-          </a:lnRef>
-          <a:fillRef idx="3">
-            <a:schemeClr val="accent1"/>
-          </a:fillRef>
-          <a:effectRef idx="2">
-            <a:schemeClr val="accent1"/>
-          </a:effectRef>
-          <a:fontRef idx="minor">
-            <a:schemeClr val="lt1"/>
-          </a:fontRef>
-        </p:style>
-        <p:txBody>
-          <a:bodyPr rtlCol="0" anchor="ctr"/>
-          <a:lstStyle/>
-          <a:p>
-            <a:pPr algn="ctr"/>
-            <a:endParaRPr/>
-          </a:p>
-        </p:txBody>
-      </p:sp>
-      <p:sp>
-        <p:nvSpPr>
-          <p:cNvPr id="4" name="TextBox 3"/>
-          <p:cNvSpPr txBox="1"/>
-          <p:nvPr/>
-        </p:nvSpPr>
-        <p:spPr>
-          <a:xfrm>
-            <a:off x="1188720" y="1097280"/>
-            <a:ext cx="9601200" cy="1097280"/>
-          </a:xfrm>
-          <a:prstGeom prst="rect">
-            <a:avLst/>
-          </a:prstGeom>
-          <a:noFill/>
-        </p:spPr>
-        <p:txBody>
-          <a:bodyPr wrap="none">
-            <a:spAutoFit/>
-          </a:bodyPr>
-          <a:lstStyle/>
-          <a:p>
-            <a:pPr>
-              <a:defRPr sz="4400" b="1">
-                <a:solidFill>
-                  <a:srgbClr val="F1F5F9"/>
-                </a:solidFill>
-              </a:defRPr>
-            </a:pPr>
-            <a:r>
-              <a:t>MIP: Intelligence Meets Execution</a:t>
-            </a:r>
-          </a:p>
-        </p:txBody>
-      </p:sp>
-      <p:sp>
-        <p:nvSpPr>
-          <p:cNvPr id="5" name="TextBox 4"/>
-          <p:cNvSpPr txBox="1"/>
-          <p:nvPr/>
-        </p:nvSpPr>
-        <p:spPr>
-          <a:xfrm>
-            <a:off x="1188720" y="2286000"/>
-            <a:ext cx="9144000" cy="548640"/>
-          </a:xfrm>
-          <a:prstGeom prst="rect">
-            <a:avLst/>
-          </a:prstGeom>
-          <a:noFill/>
-        </p:spPr>
-        <p:txBody>
-          <a:bodyPr wrap="none">
-            <a:spAutoFit/>
-          </a:bodyPr>
-          <a:lstStyle/>
-          <a:p>
-            <a:pPr>
-              <a:defRPr sz="1800">
-                <a:solidFill>
-                  <a:srgbClr val="94A3B8"/>
-                </a:solidFill>
-              </a:defRPr>
-            </a:pPr>
-            <a:r>
-              <a:t>The platform where every trade is born from evidence, governed by committee, and remembered for the future.</a:t>
-            </a:r>
-          </a:p>
-        </p:txBody>
-      </p:sp>
-      <p:sp>
-        <p:nvSpPr>
-          <p:cNvPr id="6" name="Rectangle 5"/>
-          <p:cNvSpPr/>
-          <p:nvPr/>
-        </p:nvSpPr>
-        <p:spPr>
-          <a:xfrm>
-            <a:off x="1188720" y="3017520"/>
-            <a:ext cx="3657600" cy="36576"/>
-          </a:xfrm>
-          <a:prstGeom prst="rect">
-            <a:avLst/>
-          </a:prstGeom>
-          <a:solidFill>
-            <a:srgbClr val="3069F0"/>
-          </a:solidFill>
-          <a:ln>
-            <a:noFill/>
-          </a:ln>
-        </p:spPr>
-        <p:style>
-          <a:lnRef idx="1">
-            <a:schemeClr val="accent1"/>
-          </a:lnRef>
-          <a:fillRef idx="3">
-            <a:schemeClr val="accent1"/>
-          </a:fillRef>
-          <a:effectRef idx="2">
-            <a:schemeClr val="accent1"/>
-          </a:effectRef>
-          <a:fontRef idx="minor">
-            <a:schemeClr val="lt1"/>
-          </a:fontRef>
-        </p:style>
-        <p:txBody>
-          <a:bodyPr rtlCol="0" anchor="ctr"/>
-          <a:lstStyle/>
-          <a:p>
-            <a:pPr algn="ctr"/>
-            <a:endParaRPr/>
-          </a:p>
-        </p:txBody>
-      </p:sp>
-      <p:sp>
-        <p:nvSpPr>
-          <p:cNvPr id="7" name="TextBox 6"/>
-          <p:cNvSpPr txBox="1"/>
-          <p:nvPr/>
-        </p:nvSpPr>
-        <p:spPr>
-          <a:xfrm>
-            <a:off x="1188720" y="3291840"/>
-            <a:ext cx="9144000" cy="502920"/>
-          </a:xfrm>
-          <a:prstGeom prst="rect">
-            <a:avLst/>
-          </a:prstGeom>
-          <a:noFill/>
-        </p:spPr>
-        <p:txBody>
-          <a:bodyPr wrap="square">
-            <a:spAutoFit/>
-          </a:bodyPr>
-          <a:lstStyle/>
-          <a:p>
-            <a:pPr>
-              <a:defRPr sz="1600">
-                <a:solidFill>
-                  <a:srgbClr val="CBD5E1"/>
-                </a:solidFill>
-              </a:defRPr>
-            </a:pPr>
-            <a:r>
-              <a:t>🔬  Research  —  Pattern detection, training maturity, news intelligence, parallel worlds</a:t>
-            </a:r>
-          </a:p>
-        </p:txBody>
-      </p:sp>
-      <p:sp>
-        <p:nvSpPr>
-          <p:cNvPr id="8" name="TextBox 7"/>
-          <p:cNvSpPr txBox="1"/>
-          <p:nvPr/>
-        </p:nvSpPr>
-        <p:spPr>
-          <a:xfrm>
-            <a:off x="1188720" y="3886200"/>
-            <a:ext cx="9144000" cy="502920"/>
-          </a:xfrm>
-          <a:prstGeom prst="rect">
-            <a:avLst/>
-          </a:prstGeom>
-          <a:noFill/>
-        </p:spPr>
-        <p:txBody>
-          <a:bodyPr wrap="square">
-            <a:spAutoFit/>
-          </a:bodyPr>
-          <a:lstStyle/>
-          <a:p>
-            <a:pPr>
-              <a:defRPr sz="1600">
-                <a:solidFill>
-                  <a:srgbClr val="CBD5E1"/>
-                </a:solidFill>
-              </a:defRPr>
-            </a:pPr>
-            <a:r>
-              <a:t>⚖️  Decisions  —  AI committee verdicts, reason codes, structured gates, full transparency</a:t>
-            </a:r>
-          </a:p>
-        </p:txBody>
-      </p:sp>
-      <p:sp>
-        <p:nvSpPr>
-          <p:cNvPr id="9" name="TextBox 8"/>
-          <p:cNvSpPr txBox="1"/>
-          <p:nvPr/>
-        </p:nvSpPr>
-        <p:spPr>
-          <a:xfrm>
-            <a:off x="1188720" y="4480560"/>
-            <a:ext cx="9144000" cy="502920"/>
-          </a:xfrm>
-          <a:prstGeom prst="rect">
-            <a:avLst/>
-          </a:prstGeom>
-          <a:noFill/>
-        </p:spPr>
-        <p:txBody>
-          <a:bodyPr wrap="square">
-            <a:spAutoFit/>
-          </a:bodyPr>
-          <a:lstStyle/>
-          <a:p>
-            <a:pPr>
-              <a:defRPr sz="1600">
-                <a:solidFill>
-                  <a:srgbClr val="CBD5E1"/>
-                </a:solidFill>
-              </a:defRPr>
-            </a:pPr>
-            <a:r>
-              <a:t>💹  Execution  —  Live IBKR link, position lifecycle, risk brakes, real-time sync</a:t>
-            </a:r>
-          </a:p>
-        </p:txBody>
-      </p:sp>
-      <p:sp>
-        <p:nvSpPr>
-          <p:cNvPr id="10" name="TextBox 9"/>
-          <p:cNvSpPr txBox="1"/>
-          <p:nvPr/>
-        </p:nvSpPr>
-        <p:spPr>
-          <a:xfrm>
-            <a:off x="1188720" y="5074920"/>
-            <a:ext cx="9144000" cy="502920"/>
-          </a:xfrm>
-          <a:prstGeom prst="rect">
-            <a:avLst/>
-          </a:prstGeom>
-          <a:noFill/>
-        </p:spPr>
-        <p:txBody>
-          <a:bodyPr wrap="square">
-            <a:spAutoFit/>
-          </a:bodyPr>
-          <a:lstStyle/>
-          <a:p>
-            <a:pPr>
-              <a:defRPr sz="1600">
-                <a:solidFill>
-                  <a:srgbClr val="CBD5E1"/>
-                </a:solidFill>
-              </a:defRPr>
-            </a:pPr>
-            <a:r>
-              <a:t>📚  Learning  —  Causal ledger, outcome tracking, policy feedback, continuous improvement</a:t>
-            </a:r>
-          </a:p>
-        </p:txBody>
-      </p:sp>
-      <p:sp>
-        <p:nvSpPr>
-          <p:cNvPr id="11" name="TextBox 10"/>
-          <p:cNvSpPr txBox="1"/>
-          <p:nvPr/>
-        </p:nvSpPr>
-        <p:spPr>
-          <a:xfrm>
-            <a:off x="1188720" y="5669280"/>
-            <a:ext cx="9144000" cy="457200"/>
-          </a:xfrm>
-          <a:prstGeom prst="rect">
-            <a:avLst/>
-          </a:prstGeom>
-          <a:noFill/>
-        </p:spPr>
-        <p:txBody>
-          <a:bodyPr wrap="none">
-            <a:spAutoFit/>
-          </a:bodyPr>
-          <a:lstStyle/>
-          <a:p>
-            <a:pPr>
-              <a:defRPr sz="2000" b="1">
-                <a:solidFill>
-                  <a:srgbClr val="3069F0"/>
-                </a:solidFill>
-              </a:defRPr>
-            </a:pPr>
-            <a:r>
-              <a:t>Ready to see it live?  Let's walk through the platform together.</a:t>
-            </a:r>
-          </a:p>
-        </p:txBody>
-      </p:sp>
-    </p:spTree>
-  </p:cSld>
-  <p:clrMapOvr>
-    <a:masterClrMapping/>
-  </p:clrMapOvr>
-</p:sld>
-</file>
-
-<file path=ppt/slides/slide24.xml><?xml version="1.0" encoding="utf-8"?>
-<p:sld xmlns:a="http://schemas.openxmlformats.org/drawingml/2006/main" xmlns:r="http://schemas.openxmlformats.org/officeDocument/2006/relationships" xmlns:p="http://schemas.openxmlformats.org/presentationml/2006/main">
-  <p:cSld>
-    <p:spTree>
-      <p:nvGrpSpPr>
-        <p:cNvPr id="1" name=""/>
-        <p:cNvGrpSpPr/>
-        <p:nvPr/>
-      </p:nvGrpSpPr>
-      <p:grpSpPr>
-        <a:xfrm>
-          <a:off x="0" y="0"/>
-          <a:ext cx="0" cy="0"/>
-          <a:chOff x="0" y="0"/>
-          <a:chExt cx="0" cy="0"/>
-        </a:xfrm>
-      </p:grpSpPr>
-      <p:sp>
-        <p:nvSpPr>
-          <p:cNvPr id="2" name="Rectangle 1"/>
-          <p:cNvSpPr/>
-          <p:nvPr/>
-        </p:nvSpPr>
-        <p:spPr>
-          <a:xfrm>
-            <a:off x="0" y="0"/>
-            <a:ext cx="12191695" cy="960120"/>
-          </a:xfrm>
-          <a:prstGeom prst="rect">
-            <a:avLst/>
-          </a:prstGeom>
-          <a:solidFill>
-            <a:srgbClr val="0D1540"/>
-          </a:solidFill>
-          <a:ln>
-            <a:noFill/>
-          </a:ln>
-        </p:spPr>
-        <p:style>
-          <a:lnRef idx="1">
-            <a:schemeClr val="accent1"/>
-          </a:lnRef>
-          <a:fillRef idx="3">
-            <a:schemeClr val="accent1"/>
-          </a:fillRef>
-          <a:effectRef idx="2">
-            <a:schemeClr val="accent1"/>
-          </a:effectRef>
-          <a:fontRef idx="minor">
-            <a:schemeClr val="lt1"/>
-          </a:fontRef>
-        </p:style>
-        <p:txBody>
-          <a:bodyPr rtlCol="0" anchor="ctr"/>
-          <a:lstStyle/>
-          <a:p>
-            <a:pPr algn="ctr"/>
-            <a:endParaRPr/>
-          </a:p>
-        </p:txBody>
-      </p:sp>
-      <p:sp>
-        <p:nvSpPr>
-          <p:cNvPr id="3" name="TextBox 2"/>
-          <p:cNvSpPr txBox="1"/>
-          <p:nvPr/>
-        </p:nvSpPr>
-        <p:spPr>
-          <a:xfrm>
-            <a:off x="731520" y="182880"/>
-            <a:ext cx="9144000" cy="640080"/>
-          </a:xfrm>
-          <a:prstGeom prst="rect">
-            <a:avLst/>
-          </a:prstGeom>
-          <a:noFill/>
-        </p:spPr>
-        <p:txBody>
-          <a:bodyPr wrap="square" anchor="t">
-            <a:spAutoFit/>
-          </a:bodyPr>
-          <a:lstStyle/>
-          <a:p>
-            <a:pPr algn="l"/>
-            <a:r>
-              <a:rPr sz="2800" b="1">
-                <a:solidFill>
-                  <a:srgbClr val="FFFFFF"/>
-                </a:solidFill>
-                <a:latin typeface="Segoe UI"/>
-              </a:rPr>
-              <a:t>How MIP Was Built — The AI-Orchestrated Story</a:t>
-            </a:r>
-          </a:p>
-        </p:txBody>
-      </p:sp>
-      <p:sp>
-        <p:nvSpPr>
-          <p:cNvPr id="4" name="Rectangle 3"/>
-          <p:cNvSpPr/>
-          <p:nvPr/>
-        </p:nvSpPr>
-        <p:spPr>
-          <a:xfrm>
-            <a:off x="731520" y="777240"/>
-            <a:ext cx="1371600" cy="38100"/>
-          </a:xfrm>
-          <a:prstGeom prst="rect">
-            <a:avLst/>
-          </a:prstGeom>
-          <a:solidFill>
-            <a:srgbClr val="4FC3F7"/>
-          </a:solidFill>
-          <a:ln>
-            <a:noFill/>
-          </a:ln>
-        </p:spPr>
-        <p:style>
-          <a:lnRef idx="1">
-            <a:schemeClr val="accent1"/>
-          </a:lnRef>
-          <a:fillRef idx="3">
-            <a:schemeClr val="accent1"/>
-          </a:fillRef>
-          <a:effectRef idx="2">
-            <a:schemeClr val="accent1"/>
-          </a:effectRef>
-          <a:fontRef idx="minor">
-            <a:schemeClr val="lt1"/>
-          </a:fontRef>
-        </p:style>
-        <p:txBody>
-          <a:bodyPr rtlCol="0" anchor="ctr"/>
-          <a:lstStyle/>
-          <a:p>
-            <a:pPr algn="ctr"/>
-            <a:endParaRPr/>
-          </a:p>
-        </p:txBody>
-      </p:sp>
-      <p:sp>
-        <p:nvSpPr>
-          <p:cNvPr id="5" name="TextBox 4"/>
-          <p:cNvSpPr txBox="1"/>
-          <p:nvPr/>
-        </p:nvSpPr>
-        <p:spPr>
-          <a:xfrm>
-            <a:off x="457200" y="1051560"/>
-            <a:ext cx="10972800" cy="274320"/>
-          </a:xfrm>
-          <a:prstGeom prst="rect">
-            <a:avLst/>
-          </a:prstGeom>
-          <a:noFill/>
-        </p:spPr>
-        <p:txBody>
-          <a:bodyPr wrap="square" anchor="t">
-            <a:spAutoFit/>
-          </a:bodyPr>
-          <a:lstStyle/>
-          <a:p>
-            <a:pPr algn="l"/>
-            <a:r>
-              <a:rPr sz="1300" b="1">
-                <a:solidFill>
-                  <a:srgbClr val="1A1A2E"/>
-                </a:solidFill>
-                <a:latin typeface="Segoe UI"/>
-              </a:rPr>
-              <a:t>Development Timeline — 4 months, zero lines of code typed by a human</a:t>
-            </a:r>
-          </a:p>
-        </p:txBody>
-      </p:sp>
-      <p:sp>
-        <p:nvSpPr>
-          <p:cNvPr id="6" name="Rectangle 5"/>
-          <p:cNvSpPr/>
-          <p:nvPr/>
-        </p:nvSpPr>
-        <p:spPr>
-          <a:xfrm>
-            <a:off x="457200" y="1691640"/>
-            <a:ext cx="11247120" cy="50800"/>
-          </a:xfrm>
-          <a:prstGeom prst="rect">
-            <a:avLst/>
-          </a:prstGeom>
-          <a:solidFill>
-            <a:srgbClr val="4FC3F7"/>
-          </a:solidFill>
-          <a:ln>
-            <a:noFill/>
-          </a:ln>
-        </p:spPr>
-        <p:style>
-          <a:lnRef idx="1">
-            <a:schemeClr val="accent1"/>
-          </a:lnRef>
-          <a:fillRef idx="3">
-            <a:schemeClr val="accent1"/>
-          </a:fillRef>
-          <a:effectRef idx="2">
-            <a:schemeClr val="accent1"/>
-          </a:effectRef>
-          <a:fontRef idx="minor">
-            <a:schemeClr val="lt1"/>
-          </a:fontRef>
-        </p:style>
-        <p:txBody>
-          <a:bodyPr rtlCol="0" anchor="ctr"/>
-          <a:lstStyle/>
-          <a:p>
-            <a:pPr algn="ctr"/>
-            <a:endParaRPr/>
-          </a:p>
-        </p:txBody>
-      </p:sp>
-      <p:sp>
-        <p:nvSpPr>
-          <p:cNvPr id="7" name="Oval 6"/>
-          <p:cNvSpPr/>
-          <p:nvPr/>
-        </p:nvSpPr>
-        <p:spPr>
-          <a:xfrm>
-            <a:off x="1664208" y="1545336"/>
-            <a:ext cx="329184" cy="329184"/>
-          </a:xfrm>
-          <a:prstGeom prst="ellipse">
-            <a:avLst/>
-          </a:prstGeom>
-          <a:solidFill>
-            <a:srgbClr val="0D6EFD"/>
-          </a:solidFill>
-          <a:ln>
-            <a:noFill/>
-          </a:ln>
-        </p:spPr>
-        <p:style>
-          <a:lnRef idx="1">
-            <a:schemeClr val="accent1"/>
-          </a:lnRef>
-          <a:fillRef idx="3">
-            <a:schemeClr val="accent1"/>
-          </a:fillRef>
-          <a:effectRef idx="2">
-            <a:schemeClr val="accent1"/>
-          </a:effectRef>
-          <a:fontRef idx="minor">
-            <a:schemeClr val="lt1"/>
-          </a:fontRef>
-        </p:style>
-        <p:txBody>
-          <a:bodyPr rtlCol="0" anchor="ctr"/>
-          <a:lstStyle/>
-          <a:p>
-            <a:pPr algn="ctr"/>
-            <a:endParaRPr/>
-          </a:p>
-        </p:txBody>
-      </p:sp>
-      <p:sp>
-        <p:nvSpPr>
-          <p:cNvPr id="8" name="TextBox 7"/>
-          <p:cNvSpPr txBox="1"/>
-          <p:nvPr/>
-        </p:nvSpPr>
-        <p:spPr>
-          <a:xfrm>
-            <a:off x="457200" y="1325880"/>
-            <a:ext cx="2743200" cy="274320"/>
-          </a:xfrm>
-          <a:prstGeom prst="rect">
-            <a:avLst/>
-          </a:prstGeom>
-          <a:noFill/>
-        </p:spPr>
-        <p:txBody>
-          <a:bodyPr wrap="square" anchor="t">
-            <a:spAutoFit/>
-          </a:bodyPr>
-          <a:lstStyle/>
-          <a:p>
-            <a:pPr algn="ctr"/>
-            <a:r>
-              <a:rPr sz="1000" b="1">
-                <a:solidFill>
-                  <a:srgbClr val="0D6EFD"/>
-                </a:solidFill>
-                <a:latin typeface="Segoe UI"/>
-              </a:rPr>
-              <a:t>Oct – Dec 2025</a:t>
-            </a:r>
-          </a:p>
-        </p:txBody>
-      </p:sp>
-      <p:sp>
-        <p:nvSpPr>
-          <p:cNvPr id="9" name="Rounded Rectangle 8"/>
-          <p:cNvSpPr/>
-          <p:nvPr/>
-        </p:nvSpPr>
-        <p:spPr>
-          <a:xfrm>
-            <a:off x="457200" y="1965960"/>
-            <a:ext cx="3474720" cy="1463040"/>
-          </a:xfrm>
-          <a:prstGeom prst="roundRect">
-            <a:avLst/>
-          </a:prstGeom>
-          <a:solidFill>
-            <a:srgbClr val="0D6EFD"/>
-          </a:solidFill>
-          <a:ln>
-            <a:noFill/>
-          </a:ln>
-        </p:spPr>
-        <p:style>
-          <a:lnRef idx="1">
-            <a:schemeClr val="accent1"/>
-          </a:lnRef>
-          <a:fillRef idx="3">
-            <a:schemeClr val="accent1"/>
-          </a:fillRef>
-          <a:effectRef idx="2">
-            <a:schemeClr val="accent1"/>
-          </a:effectRef>
-          <a:fontRef idx="minor">
-            <a:schemeClr val="lt1"/>
-          </a:fontRef>
-        </p:style>
-        <p:txBody>
-          <a:bodyPr rtlCol="0" anchor="ctr"/>
-          <a:lstStyle/>
-          <a:p>
-            <a:pPr algn="ctr"/>
-            <a:endParaRPr/>
-          </a:p>
-        </p:txBody>
-      </p:sp>
-      <p:sp>
-        <p:nvSpPr>
-          <p:cNvPr id="10" name="TextBox 9"/>
-          <p:cNvSpPr txBox="1"/>
-          <p:nvPr/>
-        </p:nvSpPr>
-        <p:spPr>
-          <a:xfrm>
-            <a:off x="594360" y="2011680"/>
-            <a:ext cx="3200400" cy="320040"/>
-          </a:xfrm>
-          <a:prstGeom prst="rect">
-            <a:avLst/>
-          </a:prstGeom>
-          <a:noFill/>
-        </p:spPr>
-        <p:txBody>
-          <a:bodyPr wrap="square" anchor="t">
-            <a:spAutoFit/>
-          </a:bodyPr>
-          <a:lstStyle/>
-          <a:p>
-            <a:pPr algn="l"/>
-            <a:r>
-              <a:rPr sz="1400" b="1">
-                <a:solidFill>
-                  <a:srgbClr val="FFFFFF"/>
-                </a:solidFill>
-                <a:latin typeface="Segoe UI"/>
-              </a:rPr>
-              <a:t>ChatGPT + Codex</a:t>
-            </a:r>
-          </a:p>
-        </p:txBody>
-      </p:sp>
-      <p:sp>
-        <p:nvSpPr>
-          <p:cNvPr id="11" name="TextBox 10"/>
-          <p:cNvSpPr txBox="1"/>
-          <p:nvPr/>
-        </p:nvSpPr>
-        <p:spPr>
-          <a:xfrm>
-            <a:off x="594360" y="2331720"/>
-            <a:ext cx="3200400" cy="1005840"/>
-          </a:xfrm>
-          <a:prstGeom prst="rect">
-            <a:avLst/>
-          </a:prstGeom>
-          <a:noFill/>
-        </p:spPr>
-        <p:txBody>
-          <a:bodyPr wrap="square" anchor="t">
-            <a:spAutoFit/>
-          </a:bodyPr>
-          <a:lstStyle/>
-          <a:p>
-            <a:pPr algn="l"/>
-            <a:r>
-              <a:rPr sz="1100" b="0">
-                <a:solidFill>
-                  <a:srgbClr val="DDEEFF"/>
-                </a:solidFill>
-                <a:latin typeface="Segoe UI"/>
-              </a:rPr>
-              <a:t>ChatGPT as investment SME
-&amp; solution architect.
-OpenAI Codex as developer.
-Core pipeline built.</a:t>
-            </a:r>
-          </a:p>
-        </p:txBody>
-      </p:sp>
-      <p:sp>
-        <p:nvSpPr>
-          <p:cNvPr id="12" name="Oval 11"/>
-          <p:cNvSpPr/>
-          <p:nvPr/>
-        </p:nvSpPr>
-        <p:spPr>
-          <a:xfrm>
-            <a:off x="5504688" y="1545336"/>
-            <a:ext cx="329184" cy="329184"/>
-          </a:xfrm>
-          <a:prstGeom prst="ellipse">
-            <a:avLst/>
-          </a:prstGeom>
-          <a:solidFill>
-            <a:srgbClr val="6F42C1"/>
-          </a:solidFill>
-          <a:ln>
-            <a:noFill/>
-          </a:ln>
-        </p:spPr>
-        <p:style>
-          <a:lnRef idx="1">
-            <a:schemeClr val="accent1"/>
-          </a:lnRef>
-          <a:fillRef idx="3">
-            <a:schemeClr val="accent1"/>
-          </a:fillRef>
-          <a:effectRef idx="2">
-            <a:schemeClr val="accent1"/>
-          </a:effectRef>
-          <a:fontRef idx="minor">
-            <a:schemeClr val="lt1"/>
-          </a:fontRef>
-        </p:style>
-        <p:txBody>
-          <a:bodyPr rtlCol="0" anchor="ctr"/>
-          <a:lstStyle/>
-          <a:p>
-            <a:pPr algn="ctr"/>
-            <a:endParaRPr/>
-          </a:p>
-        </p:txBody>
-      </p:sp>
-      <p:sp>
-        <p:nvSpPr>
-          <p:cNvPr id="13" name="TextBox 12"/>
-          <p:cNvSpPr txBox="1"/>
-          <p:nvPr/>
-        </p:nvSpPr>
-        <p:spPr>
-          <a:xfrm>
-            <a:off x="4297680" y="1325880"/>
-            <a:ext cx="2743200" cy="274320"/>
-          </a:xfrm>
-          <a:prstGeom prst="rect">
-            <a:avLst/>
-          </a:prstGeom>
-          <a:noFill/>
-        </p:spPr>
-        <p:txBody>
-          <a:bodyPr wrap="square" anchor="t">
-            <a:spAutoFit/>
-          </a:bodyPr>
-          <a:lstStyle/>
-          <a:p>
-            <a:pPr algn="ctr"/>
-            <a:r>
-              <a:rPr sz="1000" b="1">
-                <a:solidFill>
-                  <a:srgbClr val="6F42C1"/>
-                </a:solidFill>
-                <a:latin typeface="Segoe UI"/>
-              </a:rPr>
-              <a:t>Jan 2026</a:t>
-            </a:r>
-          </a:p>
-        </p:txBody>
-      </p:sp>
-      <p:sp>
-        <p:nvSpPr>
-          <p:cNvPr id="14" name="Rounded Rectangle 13"/>
-          <p:cNvSpPr/>
-          <p:nvPr/>
-        </p:nvSpPr>
-        <p:spPr>
-          <a:xfrm>
-            <a:off x="4297680" y="1965960"/>
-            <a:ext cx="3474720" cy="1463040"/>
-          </a:xfrm>
-          <a:prstGeom prst="roundRect">
-            <a:avLst/>
-          </a:prstGeom>
-          <a:solidFill>
-            <a:srgbClr val="6F42C1"/>
-          </a:solidFill>
-          <a:ln>
-            <a:noFill/>
-          </a:ln>
-        </p:spPr>
-        <p:style>
-          <a:lnRef idx="1">
-            <a:schemeClr val="accent1"/>
-          </a:lnRef>
-          <a:fillRef idx="3">
-            <a:schemeClr val="accent1"/>
-          </a:fillRef>
-          <a:effectRef idx="2">
-            <a:schemeClr val="accent1"/>
-          </a:effectRef>
-          <a:fontRef idx="minor">
-            <a:schemeClr val="lt1"/>
-          </a:fontRef>
-        </p:style>
-        <p:txBody>
-          <a:bodyPr rtlCol="0" anchor="ctr"/>
-          <a:lstStyle/>
-          <a:p>
-            <a:pPr algn="ctr"/>
-            <a:endParaRPr/>
-          </a:p>
-        </p:txBody>
-      </p:sp>
-      <p:sp>
-        <p:nvSpPr>
-          <p:cNvPr id="15" name="TextBox 14"/>
-          <p:cNvSpPr txBox="1"/>
-          <p:nvPr/>
-        </p:nvSpPr>
-        <p:spPr>
-          <a:xfrm>
-            <a:off x="4434840" y="2011680"/>
-            <a:ext cx="3200400" cy="320040"/>
-          </a:xfrm>
-          <a:prstGeom prst="rect">
-            <a:avLst/>
-          </a:prstGeom>
-          <a:noFill/>
-        </p:spPr>
-        <p:txBody>
-          <a:bodyPr wrap="square" anchor="t">
-            <a:spAutoFit/>
-          </a:bodyPr>
-          <a:lstStyle/>
-          <a:p>
-            <a:pPr algn="l"/>
-            <a:r>
-              <a:rPr sz="1400" b="1">
-                <a:solidFill>
-                  <a:srgbClr val="FFFFFF"/>
-                </a:solidFill>
-                <a:latin typeface="Segoe UI"/>
-              </a:rPr>
-              <a:t>Transition to Cursor</a:t>
-            </a:r>
-          </a:p>
-        </p:txBody>
-      </p:sp>
-      <p:sp>
-        <p:nvSpPr>
-          <p:cNvPr id="16" name="TextBox 15"/>
-          <p:cNvSpPr txBox="1"/>
-          <p:nvPr/>
-        </p:nvSpPr>
-        <p:spPr>
-          <a:xfrm>
-            <a:off x="4434840" y="2331720"/>
-            <a:ext cx="3200400" cy="769441"/>
-          </a:xfrm>
-          <a:prstGeom prst="rect">
-            <a:avLst/>
-          </a:prstGeom>
-          <a:noFill/>
-        </p:spPr>
-        <p:txBody>
-          <a:bodyPr wrap="square" anchor="t">
-            <a:spAutoFit/>
-          </a:bodyPr>
-          <a:lstStyle/>
-          <a:p>
-            <a:pPr algn="l"/>
-            <a:r>
-              <a:rPr sz="1100" b="0" dirty="0">
-                <a:solidFill>
-                  <a:srgbClr val="DDEEFF"/>
-                </a:solidFill>
-                <a:latin typeface="Segoe UI"/>
-              </a:rPr>
-              <a:t>Switched to Cursor (Claude)
-for </a:t>
-            </a:r>
-            <a:r>
-              <a:rPr lang="de-DE" sz="1100" b="0" dirty="0" err="1">
-                <a:solidFill>
-                  <a:srgbClr val="DDEEFF"/>
-                </a:solidFill>
-                <a:latin typeface="Segoe UI"/>
-              </a:rPr>
-              <a:t>development</a:t>
-            </a:r>
-            <a:r>
-              <a:rPr lang="de-DE" sz="1100" b="0" dirty="0">
-                <a:solidFill>
-                  <a:srgbClr val="DDEEFF"/>
-                </a:solidFill>
-                <a:latin typeface="Segoe UI"/>
-              </a:rPr>
-              <a:t> &amp; </a:t>
-            </a:r>
-            <a:r>
-              <a:rPr sz="1100" b="0" dirty="0">
-                <a:solidFill>
-                  <a:srgbClr val="DDEEFF"/>
-                </a:solidFill>
-                <a:latin typeface="Segoe UI"/>
-              </a:rPr>
-              <a:t>implementation.
-ChatGPT for requirements
-&amp; idea validation.</a:t>
-            </a:r>
-          </a:p>
-        </p:txBody>
-      </p:sp>
-      <p:sp>
-        <p:nvSpPr>
-          <p:cNvPr id="17" name="Oval 16"/>
-          <p:cNvSpPr/>
-          <p:nvPr/>
-        </p:nvSpPr>
-        <p:spPr>
-          <a:xfrm>
-            <a:off x="9345168" y="1545336"/>
-            <a:ext cx="329184" cy="329184"/>
-          </a:xfrm>
-          <a:prstGeom prst="ellipse">
-            <a:avLst/>
-          </a:prstGeom>
-          <a:solidFill>
-            <a:srgbClr val="198754"/>
-          </a:solidFill>
-          <a:ln>
-            <a:noFill/>
-          </a:ln>
-        </p:spPr>
-        <p:style>
-          <a:lnRef idx="1">
-            <a:schemeClr val="accent1"/>
-          </a:lnRef>
-          <a:fillRef idx="3">
-            <a:schemeClr val="accent1"/>
-          </a:fillRef>
-          <a:effectRef idx="2">
-            <a:schemeClr val="accent1"/>
-          </a:effectRef>
-          <a:fontRef idx="minor">
-            <a:schemeClr val="lt1"/>
-          </a:fontRef>
-        </p:style>
-        <p:txBody>
-          <a:bodyPr rtlCol="0" anchor="ctr"/>
-          <a:lstStyle/>
-          <a:p>
-            <a:pPr algn="ctr"/>
-            <a:endParaRPr/>
-          </a:p>
-        </p:txBody>
-      </p:sp>
-      <p:sp>
-        <p:nvSpPr>
-          <p:cNvPr id="18" name="TextBox 17"/>
-          <p:cNvSpPr txBox="1"/>
-          <p:nvPr/>
-        </p:nvSpPr>
-        <p:spPr>
-          <a:xfrm>
-            <a:off x="8138160" y="1325880"/>
-            <a:ext cx="2743200" cy="274320"/>
-          </a:xfrm>
-          <a:prstGeom prst="rect">
-            <a:avLst/>
-          </a:prstGeom>
-          <a:noFill/>
-        </p:spPr>
-        <p:txBody>
-          <a:bodyPr wrap="square" anchor="t">
-            <a:spAutoFit/>
-          </a:bodyPr>
-          <a:lstStyle/>
-          <a:p>
-            <a:pPr algn="ctr"/>
-            <a:r>
-              <a:rPr sz="1000" b="1">
-                <a:solidFill>
-                  <a:srgbClr val="198754"/>
-                </a:solidFill>
-                <a:latin typeface="Segoe UI"/>
-              </a:rPr>
-              <a:t>Feb 2026</a:t>
-            </a:r>
-          </a:p>
-        </p:txBody>
-      </p:sp>
-      <p:sp>
-        <p:nvSpPr>
-          <p:cNvPr id="19" name="Rounded Rectangle 18"/>
-          <p:cNvSpPr/>
-          <p:nvPr/>
-        </p:nvSpPr>
-        <p:spPr>
-          <a:xfrm>
-            <a:off x="8138160" y="1965960"/>
-            <a:ext cx="3474720" cy="1463040"/>
-          </a:xfrm>
-          <a:prstGeom prst="roundRect">
-            <a:avLst/>
-          </a:prstGeom>
-          <a:solidFill>
-            <a:srgbClr val="198754"/>
-          </a:solidFill>
-          <a:ln>
-            <a:noFill/>
-          </a:ln>
-        </p:spPr>
-        <p:style>
-          <a:lnRef idx="1">
-            <a:schemeClr val="accent1"/>
-          </a:lnRef>
-          <a:fillRef idx="3">
-            <a:schemeClr val="accent1"/>
-          </a:fillRef>
-          <a:effectRef idx="2">
-            <a:schemeClr val="accent1"/>
-          </a:effectRef>
-          <a:fontRef idx="minor">
-            <a:schemeClr val="lt1"/>
-          </a:fontRef>
-        </p:style>
-        <p:txBody>
-          <a:bodyPr rtlCol="0" anchor="ctr"/>
-          <a:lstStyle/>
-          <a:p>
-            <a:pPr algn="ctr"/>
-            <a:endParaRPr/>
-          </a:p>
-        </p:txBody>
-      </p:sp>
-      <p:sp>
-        <p:nvSpPr>
-          <p:cNvPr id="20" name="TextBox 19"/>
-          <p:cNvSpPr txBox="1"/>
-          <p:nvPr/>
-        </p:nvSpPr>
-        <p:spPr>
-          <a:xfrm>
-            <a:off x="8275320" y="2011680"/>
-            <a:ext cx="3200400" cy="320040"/>
-          </a:xfrm>
-          <a:prstGeom prst="rect">
-            <a:avLst/>
-          </a:prstGeom>
-          <a:noFill/>
-        </p:spPr>
-        <p:txBody>
-          <a:bodyPr wrap="square" anchor="t">
-            <a:spAutoFit/>
-          </a:bodyPr>
-          <a:lstStyle/>
-          <a:p>
-            <a:pPr algn="l"/>
-            <a:r>
-              <a:rPr sz="1400" b="1">
-                <a:solidFill>
-                  <a:srgbClr val="FFFFFF"/>
-                </a:solidFill>
-                <a:latin typeface="Segoe UI"/>
-              </a:rPr>
-              <a:t>Full Cursor Autonomy</a:t>
-            </a:r>
-          </a:p>
-        </p:txBody>
-      </p:sp>
-      <p:sp>
-        <p:nvSpPr>
-          <p:cNvPr id="21" name="TextBox 20"/>
-          <p:cNvSpPr txBox="1"/>
-          <p:nvPr/>
-        </p:nvSpPr>
-        <p:spPr>
-          <a:xfrm>
-            <a:off x="8275320" y="2331720"/>
-            <a:ext cx="3200400" cy="1005840"/>
-          </a:xfrm>
-          <a:prstGeom prst="rect">
-            <a:avLst/>
-          </a:prstGeom>
-          <a:noFill/>
-        </p:spPr>
-        <p:txBody>
-          <a:bodyPr wrap="square" anchor="t">
-            <a:spAutoFit/>
-          </a:bodyPr>
-          <a:lstStyle/>
-          <a:p>
-            <a:pPr algn="l"/>
-            <a:r>
-              <a:rPr sz="1100" b="0">
-                <a:solidFill>
-                  <a:srgbClr val="DDEEFF"/>
-                </a:solidFill>
-                <a:latin typeface="Segoe UI"/>
-              </a:rPr>
-              <a:t>Cursor deploys direct to
-Snowflake. Testing, debugging,
-data repairs — all autonomous.
-Human reviews, never types.</a:t>
-            </a:r>
-          </a:p>
-        </p:txBody>
-      </p:sp>
-      <p:sp>
-        <p:nvSpPr>
-          <p:cNvPr id="22" name="TextBox 21"/>
-          <p:cNvSpPr txBox="1"/>
-          <p:nvPr/>
-        </p:nvSpPr>
-        <p:spPr>
-          <a:xfrm>
-            <a:off x="457200" y="3611880"/>
-            <a:ext cx="2743200" cy="292388"/>
-          </a:xfrm>
-          <a:prstGeom prst="rect">
-            <a:avLst/>
-          </a:prstGeom>
-          <a:noFill/>
-        </p:spPr>
-        <p:txBody>
-          <a:bodyPr wrap="square" anchor="t">
-            <a:spAutoFit/>
-          </a:bodyPr>
-          <a:lstStyle/>
-          <a:p>
-            <a:pPr algn="l"/>
-            <a:r>
-              <a:rPr lang="de-DE" sz="1300" b="1" dirty="0" err="1">
-                <a:solidFill>
-                  <a:srgbClr val="1A1A2E"/>
-                </a:solidFill>
-                <a:latin typeface="Segoe UI"/>
-              </a:rPr>
-              <a:t>Kenneth‘s</a:t>
-            </a:r>
-            <a:r>
-              <a:rPr sz="1300" b="1" dirty="0">
-                <a:solidFill>
-                  <a:srgbClr val="1A1A2E"/>
-                </a:solidFill>
-                <a:latin typeface="Segoe UI"/>
-              </a:rPr>
-              <a:t> Role</a:t>
-            </a:r>
-          </a:p>
-        </p:txBody>
-      </p:sp>
-      <p:sp>
-        <p:nvSpPr>
-          <p:cNvPr id="23" name="Rounded Rectangle 22"/>
-          <p:cNvSpPr/>
-          <p:nvPr/>
-        </p:nvSpPr>
-        <p:spPr>
-          <a:xfrm>
-            <a:off x="457200" y="3931920"/>
-            <a:ext cx="2057400" cy="1005840"/>
-          </a:xfrm>
-          <a:prstGeom prst="roundRect">
-            <a:avLst/>
-          </a:prstGeom>
-          <a:solidFill>
-            <a:srgbClr val="F8F9FA"/>
-          </a:solidFill>
-          <a:ln w="12700">
-            <a:solidFill>
-              <a:srgbClr val="E9ECEF"/>
-            </a:solidFill>
-          </a:ln>
-        </p:spPr>
-        <p:style>
-          <a:lnRef idx="1">
-            <a:schemeClr val="accent1"/>
-          </a:lnRef>
-          <a:fillRef idx="3">
-            <a:schemeClr val="accent1"/>
-          </a:fillRef>
-          <a:effectRef idx="2">
-            <a:schemeClr val="accent1"/>
-          </a:effectRef>
-          <a:fontRef idx="minor">
-            <a:schemeClr val="lt1"/>
-          </a:fontRef>
-        </p:style>
-        <p:txBody>
-          <a:bodyPr rtlCol="0" anchor="ctr"/>
-          <a:lstStyle/>
-          <a:p>
-            <a:pPr algn="ctr"/>
-            <a:endParaRPr/>
-          </a:p>
-        </p:txBody>
-      </p:sp>
-      <p:sp>
-        <p:nvSpPr>
-          <p:cNvPr id="24" name="Rectangle 23"/>
-          <p:cNvSpPr/>
-          <p:nvPr/>
-        </p:nvSpPr>
-        <p:spPr>
-          <a:xfrm>
-            <a:off x="457200" y="3931920"/>
-            <a:ext cx="63500" cy="1005840"/>
-          </a:xfrm>
-          <a:prstGeom prst="rect">
-            <a:avLst/>
-          </a:prstGeom>
-          <a:solidFill>
-            <a:srgbClr val="4FC3F7"/>
-          </a:solidFill>
-          <a:ln>
-            <a:noFill/>
-          </a:ln>
-        </p:spPr>
-        <p:style>
-          <a:lnRef idx="1">
-            <a:schemeClr val="accent1"/>
-          </a:lnRef>
-          <a:fillRef idx="3">
-            <a:schemeClr val="accent1"/>
-          </a:fillRef>
-          <a:effectRef idx="2">
-            <a:schemeClr val="accent1"/>
-          </a:effectRef>
-          <a:fontRef idx="minor">
-            <a:schemeClr val="lt1"/>
-          </a:fontRef>
-        </p:style>
-        <p:txBody>
-          <a:bodyPr rtlCol="0" anchor="ctr"/>
-          <a:lstStyle/>
-          <a:p>
-            <a:pPr algn="ctr"/>
-            <a:endParaRPr/>
-          </a:p>
-        </p:txBody>
-      </p:sp>
-      <p:sp>
-        <p:nvSpPr>
-          <p:cNvPr id="25" name="TextBox 24"/>
-          <p:cNvSpPr txBox="1"/>
-          <p:nvPr/>
-        </p:nvSpPr>
-        <p:spPr>
-          <a:xfrm>
-            <a:off x="640080" y="3977640"/>
-            <a:ext cx="1645920" cy="320040"/>
-          </a:xfrm>
-          <a:prstGeom prst="rect">
-            <a:avLst/>
-          </a:prstGeom>
-          <a:noFill/>
-        </p:spPr>
-        <p:txBody>
-          <a:bodyPr wrap="square" anchor="t">
-            <a:spAutoFit/>
-          </a:bodyPr>
-          <a:lstStyle/>
-          <a:p>
-            <a:pPr algn="l"/>
-            <a:r>
-              <a:rPr sz="1200" b="1">
-                <a:solidFill>
-                  <a:srgbClr val="1A1A2E"/>
-                </a:solidFill>
-                <a:latin typeface="Segoe UI"/>
-              </a:rPr>
-              <a:t>⭐  Visionary</a:t>
-            </a:r>
-          </a:p>
-        </p:txBody>
-      </p:sp>
-      <p:sp>
-        <p:nvSpPr>
-          <p:cNvPr id="26" name="TextBox 25"/>
-          <p:cNvSpPr txBox="1"/>
-          <p:nvPr/>
-        </p:nvSpPr>
-        <p:spPr>
-          <a:xfrm>
-            <a:off x="640080" y="4297680"/>
-            <a:ext cx="1737360" cy="548640"/>
-          </a:xfrm>
-          <a:prstGeom prst="rect">
-            <a:avLst/>
-          </a:prstGeom>
-          <a:noFill/>
-        </p:spPr>
-        <p:txBody>
-          <a:bodyPr wrap="square" anchor="t">
-            <a:spAutoFit/>
-          </a:bodyPr>
-          <a:lstStyle/>
-          <a:p>
-            <a:pPr algn="l"/>
-            <a:r>
-              <a:rPr sz="1000" b="0">
-                <a:solidFill>
-                  <a:srgbClr val="6C757D"/>
-                </a:solidFill>
-                <a:latin typeface="Segoe UI"/>
-              </a:rPr>
-              <a:t>Conceived the mission.
-Defined what MIP should become.</a:t>
-            </a:r>
-          </a:p>
-        </p:txBody>
-      </p:sp>
-      <p:sp>
-        <p:nvSpPr>
-          <p:cNvPr id="27" name="Rounded Rectangle 26"/>
-          <p:cNvSpPr/>
-          <p:nvPr/>
-        </p:nvSpPr>
-        <p:spPr>
-          <a:xfrm>
-            <a:off x="2697480" y="3931920"/>
-            <a:ext cx="2057400" cy="1005840"/>
-          </a:xfrm>
-          <a:prstGeom prst="roundRect">
-            <a:avLst/>
-          </a:prstGeom>
-          <a:solidFill>
-            <a:srgbClr val="F8F9FA"/>
-          </a:solidFill>
-          <a:ln w="12700">
-            <a:solidFill>
-              <a:srgbClr val="E9ECEF"/>
-            </a:solidFill>
-          </a:ln>
-        </p:spPr>
-        <p:style>
-          <a:lnRef idx="1">
-            <a:schemeClr val="accent1"/>
-          </a:lnRef>
-          <a:fillRef idx="3">
-            <a:schemeClr val="accent1"/>
-          </a:fillRef>
-          <a:effectRef idx="2">
-            <a:schemeClr val="accent1"/>
-          </a:effectRef>
-          <a:fontRef idx="minor">
-            <a:schemeClr val="lt1"/>
-          </a:fontRef>
-        </p:style>
-        <p:txBody>
-          <a:bodyPr rtlCol="0" anchor="ctr"/>
-          <a:lstStyle/>
-          <a:p>
-            <a:pPr algn="ctr"/>
-            <a:endParaRPr/>
-          </a:p>
-        </p:txBody>
-      </p:sp>
-      <p:sp>
-        <p:nvSpPr>
-          <p:cNvPr id="28" name="Rectangle 27"/>
-          <p:cNvSpPr/>
-          <p:nvPr/>
-        </p:nvSpPr>
-        <p:spPr>
-          <a:xfrm>
-            <a:off x="2697480" y="3931920"/>
-            <a:ext cx="63500" cy="1005840"/>
-          </a:xfrm>
-          <a:prstGeom prst="rect">
-            <a:avLst/>
-          </a:prstGeom>
-          <a:solidFill>
-            <a:srgbClr val="4FC3F7"/>
-          </a:solidFill>
-          <a:ln>
-            <a:noFill/>
-          </a:ln>
-        </p:spPr>
-        <p:style>
-          <a:lnRef idx="1">
-            <a:schemeClr val="accent1"/>
-          </a:lnRef>
-          <a:fillRef idx="3">
-            <a:schemeClr val="accent1"/>
-          </a:fillRef>
-          <a:effectRef idx="2">
-            <a:schemeClr val="accent1"/>
-          </a:effectRef>
-          <a:fontRef idx="minor">
-            <a:schemeClr val="lt1"/>
-          </a:fontRef>
-        </p:style>
-        <p:txBody>
-          <a:bodyPr rtlCol="0" anchor="ctr"/>
-          <a:lstStyle/>
-          <a:p>
-            <a:pPr algn="ctr"/>
-            <a:endParaRPr/>
-          </a:p>
-        </p:txBody>
-      </p:sp>
-      <p:sp>
-        <p:nvSpPr>
-          <p:cNvPr id="29" name="TextBox 28"/>
-          <p:cNvSpPr txBox="1"/>
-          <p:nvPr/>
-        </p:nvSpPr>
-        <p:spPr>
-          <a:xfrm>
-            <a:off x="2880360" y="3977640"/>
-            <a:ext cx="1645920" cy="320040"/>
-          </a:xfrm>
-          <a:prstGeom prst="rect">
-            <a:avLst/>
-          </a:prstGeom>
-          <a:noFill/>
-        </p:spPr>
-        <p:txBody>
-          <a:bodyPr wrap="square" anchor="t">
-            <a:spAutoFit/>
-          </a:bodyPr>
-          <a:lstStyle/>
-          <a:p>
-            <a:pPr algn="l"/>
-            <a:r>
-              <a:rPr sz="1200" b="1">
-                <a:solidFill>
-                  <a:srgbClr val="1A1A2E"/>
-                </a:solidFill>
-                <a:latin typeface="Segoe UI"/>
-              </a:rPr>
-              <a:t>⚙  Orchestrator</a:t>
-            </a:r>
-          </a:p>
-        </p:txBody>
-      </p:sp>
-      <p:sp>
-        <p:nvSpPr>
-          <p:cNvPr id="30" name="TextBox 29"/>
-          <p:cNvSpPr txBox="1"/>
-          <p:nvPr/>
-        </p:nvSpPr>
-        <p:spPr>
-          <a:xfrm>
-            <a:off x="2880360" y="4297680"/>
-            <a:ext cx="1737360" cy="548640"/>
-          </a:xfrm>
-          <a:prstGeom prst="rect">
-            <a:avLst/>
-          </a:prstGeom>
-          <a:noFill/>
-        </p:spPr>
-        <p:txBody>
-          <a:bodyPr wrap="square" anchor="t">
-            <a:spAutoFit/>
-          </a:bodyPr>
-          <a:lstStyle/>
-          <a:p>
-            <a:pPr algn="l"/>
-            <a:r>
-              <a:rPr sz="1000" b="0">
-                <a:solidFill>
-                  <a:srgbClr val="6C757D"/>
-                </a:solidFill>
-                <a:latin typeface="Segoe UI"/>
-              </a:rPr>
-              <a:t>Directed the AI agents.
-Reviewed output, steered direction.</a:t>
-            </a:r>
-          </a:p>
-        </p:txBody>
-      </p:sp>
-      <p:sp>
-        <p:nvSpPr>
-          <p:cNvPr id="31" name="Rounded Rectangle 30"/>
-          <p:cNvSpPr/>
-          <p:nvPr/>
-        </p:nvSpPr>
-        <p:spPr>
-          <a:xfrm>
-            <a:off x="4937760" y="3931920"/>
-            <a:ext cx="2057400" cy="1005840"/>
-          </a:xfrm>
-          <a:prstGeom prst="roundRect">
-            <a:avLst/>
-          </a:prstGeom>
-          <a:solidFill>
-            <a:srgbClr val="F8F9FA"/>
-          </a:solidFill>
-          <a:ln w="12700">
-            <a:solidFill>
-              <a:srgbClr val="E9ECEF"/>
-            </a:solidFill>
-          </a:ln>
-        </p:spPr>
-        <p:style>
-          <a:lnRef idx="1">
-            <a:schemeClr val="accent1"/>
-          </a:lnRef>
-          <a:fillRef idx="3">
-            <a:schemeClr val="accent1"/>
-          </a:fillRef>
-          <a:effectRef idx="2">
-            <a:schemeClr val="accent1"/>
-          </a:effectRef>
-          <a:fontRef idx="minor">
-            <a:schemeClr val="lt1"/>
-          </a:fontRef>
-        </p:style>
-        <p:txBody>
-          <a:bodyPr rtlCol="0" anchor="ctr"/>
-          <a:lstStyle/>
-          <a:p>
-            <a:pPr algn="ctr"/>
-            <a:endParaRPr/>
-          </a:p>
-        </p:txBody>
-      </p:sp>
-      <p:sp>
-        <p:nvSpPr>
-          <p:cNvPr id="32" name="Rectangle 31"/>
-          <p:cNvSpPr/>
-          <p:nvPr/>
-        </p:nvSpPr>
-        <p:spPr>
-          <a:xfrm>
-            <a:off x="4937760" y="3931920"/>
-            <a:ext cx="63500" cy="1005840"/>
-          </a:xfrm>
-          <a:prstGeom prst="rect">
-            <a:avLst/>
-          </a:prstGeom>
-          <a:solidFill>
-            <a:srgbClr val="4FC3F7"/>
-          </a:solidFill>
-          <a:ln>
-            <a:noFill/>
-          </a:ln>
-        </p:spPr>
-        <p:style>
-          <a:lnRef idx="1">
-            <a:schemeClr val="accent1"/>
-          </a:lnRef>
-          <a:fillRef idx="3">
-            <a:schemeClr val="accent1"/>
-          </a:fillRef>
-          <a:effectRef idx="2">
-            <a:schemeClr val="accent1"/>
-          </a:effectRef>
-          <a:fontRef idx="minor">
-            <a:schemeClr val="lt1"/>
-          </a:fontRef>
-        </p:style>
-        <p:txBody>
-          <a:bodyPr rtlCol="0" anchor="ctr"/>
-          <a:lstStyle/>
-          <a:p>
-            <a:pPr algn="ctr"/>
-            <a:endParaRPr/>
-          </a:p>
-        </p:txBody>
-      </p:sp>
-      <p:sp>
-        <p:nvSpPr>
-          <p:cNvPr id="33" name="TextBox 32"/>
-          <p:cNvSpPr txBox="1"/>
-          <p:nvPr/>
-        </p:nvSpPr>
-        <p:spPr>
-          <a:xfrm>
-            <a:off x="5120640" y="3977640"/>
-            <a:ext cx="1645920" cy="320040"/>
-          </a:xfrm>
-          <a:prstGeom prst="rect">
-            <a:avLst/>
-          </a:prstGeom>
-          <a:noFill/>
-        </p:spPr>
-        <p:txBody>
-          <a:bodyPr wrap="square" anchor="t">
-            <a:spAutoFit/>
-          </a:bodyPr>
-          <a:lstStyle/>
-          <a:p>
-            <a:pPr algn="l"/>
-            <a:r>
-              <a:rPr sz="1200" b="1">
-                <a:solidFill>
-                  <a:srgbClr val="1A1A2E"/>
-                </a:solidFill>
-                <a:latin typeface="Segoe UI"/>
-              </a:rPr>
-              <a:t>☑  Product Owner</a:t>
-            </a:r>
-          </a:p>
-        </p:txBody>
-      </p:sp>
-      <p:sp>
-        <p:nvSpPr>
-          <p:cNvPr id="34" name="TextBox 33"/>
-          <p:cNvSpPr txBox="1"/>
-          <p:nvPr/>
-        </p:nvSpPr>
-        <p:spPr>
-          <a:xfrm>
-            <a:off x="5120640" y="4297680"/>
-            <a:ext cx="1737360" cy="548640"/>
-          </a:xfrm>
-          <a:prstGeom prst="rect">
-            <a:avLst/>
-          </a:prstGeom>
-          <a:noFill/>
-        </p:spPr>
-        <p:txBody>
-          <a:bodyPr wrap="square" anchor="t">
-            <a:spAutoFit/>
-          </a:bodyPr>
-          <a:lstStyle/>
-          <a:p>
-            <a:pPr algn="l"/>
-            <a:r>
-              <a:rPr sz="1000" b="0">
-                <a:solidFill>
-                  <a:srgbClr val="6C757D"/>
-                </a:solidFill>
-                <a:latin typeface="Segoe UI"/>
-              </a:rPr>
-              <a:t>Prioritised features.
-Defined acceptance criteria.</a:t>
-            </a:r>
-          </a:p>
-        </p:txBody>
-      </p:sp>
-      <p:sp>
-        <p:nvSpPr>
-          <p:cNvPr id="35" name="TextBox 34"/>
-          <p:cNvSpPr txBox="1"/>
-          <p:nvPr/>
-        </p:nvSpPr>
-        <p:spPr>
-          <a:xfrm>
-            <a:off x="7132320" y="3611880"/>
-            <a:ext cx="4572000" cy="274320"/>
-          </a:xfrm>
-          <a:prstGeom prst="rect">
-            <a:avLst/>
-          </a:prstGeom>
-          <a:noFill/>
-        </p:spPr>
-        <p:txBody>
-          <a:bodyPr wrap="square" anchor="t">
-            <a:spAutoFit/>
-          </a:bodyPr>
-          <a:lstStyle/>
-          <a:p>
-            <a:pPr algn="l"/>
-            <a:r>
-              <a:rPr sz="1300" b="1">
-                <a:solidFill>
-                  <a:srgbClr val="1A1A2E"/>
-                </a:solidFill>
-                <a:latin typeface="Segoe UI"/>
-              </a:rPr>
-              <a:t>The Numbers</a:t>
-            </a:r>
-          </a:p>
-        </p:txBody>
-      </p:sp>
-      <p:sp>
-        <p:nvSpPr>
-          <p:cNvPr id="36" name="Rectangle 35"/>
-          <p:cNvSpPr/>
-          <p:nvPr/>
-        </p:nvSpPr>
-        <p:spPr>
-          <a:xfrm>
-            <a:off x="7132320" y="3931920"/>
-            <a:ext cx="4754880" cy="274320"/>
-          </a:xfrm>
-          <a:prstGeom prst="rect">
-            <a:avLst/>
-          </a:prstGeom>
-          <a:solidFill>
-            <a:srgbClr val="0D1540"/>
-          </a:solidFill>
-          <a:ln>
-            <a:noFill/>
-          </a:ln>
-        </p:spPr>
-        <p:style>
-          <a:lnRef idx="1">
-            <a:schemeClr val="accent1"/>
-          </a:lnRef>
-          <a:fillRef idx="3">
-            <a:schemeClr val="accent1"/>
-          </a:fillRef>
-          <a:effectRef idx="2">
-            <a:schemeClr val="accent1"/>
-          </a:effectRef>
-          <a:fontRef idx="minor">
-            <a:schemeClr val="lt1"/>
-          </a:fontRef>
-        </p:style>
-        <p:txBody>
-          <a:bodyPr rtlCol="0" anchor="ctr"/>
-          <a:lstStyle/>
-          <a:p>
-            <a:pPr algn="ctr"/>
-            <a:endParaRPr/>
-          </a:p>
-        </p:txBody>
-      </p:sp>
-      <p:sp>
-        <p:nvSpPr>
-          <p:cNvPr id="37" name="TextBox 36"/>
-          <p:cNvSpPr txBox="1"/>
-          <p:nvPr/>
-        </p:nvSpPr>
-        <p:spPr>
-          <a:xfrm>
-            <a:off x="7178040" y="3950208"/>
-            <a:ext cx="1828800" cy="228600"/>
-          </a:xfrm>
-          <a:prstGeom prst="rect">
-            <a:avLst/>
-          </a:prstGeom>
-          <a:noFill/>
-        </p:spPr>
-        <p:txBody>
-          <a:bodyPr wrap="square" anchor="t">
-            <a:spAutoFit/>
-          </a:bodyPr>
-          <a:lstStyle/>
-          <a:p>
-            <a:pPr algn="ctr"/>
-            <a:r>
-              <a:rPr sz="900" b="1">
-                <a:solidFill>
-                  <a:srgbClr val="FFFFFF"/>
-                </a:solidFill>
-                <a:latin typeface="Segoe UI"/>
-              </a:rPr>
-              <a:t>Layer</a:t>
-            </a:r>
-          </a:p>
-        </p:txBody>
-      </p:sp>
-      <p:sp>
-        <p:nvSpPr>
-          <p:cNvPr id="38" name="TextBox 37"/>
-          <p:cNvSpPr txBox="1"/>
-          <p:nvPr/>
-        </p:nvSpPr>
-        <p:spPr>
-          <a:xfrm>
-            <a:off x="9006840" y="3950208"/>
-            <a:ext cx="822960" cy="228600"/>
-          </a:xfrm>
-          <a:prstGeom prst="rect">
-            <a:avLst/>
-          </a:prstGeom>
-          <a:noFill/>
-        </p:spPr>
-        <p:txBody>
-          <a:bodyPr wrap="square" anchor="t">
-            <a:spAutoFit/>
-          </a:bodyPr>
-          <a:lstStyle/>
-          <a:p>
-            <a:pPr algn="ctr"/>
-            <a:r>
-              <a:rPr sz="900" b="1">
-                <a:solidFill>
-                  <a:srgbClr val="FFFFFF"/>
-                </a:solidFill>
-                <a:latin typeface="Segoe UI"/>
-              </a:rPr>
-              <a:t>Files</a:t>
-            </a:r>
-          </a:p>
-        </p:txBody>
-      </p:sp>
-      <p:sp>
-        <p:nvSpPr>
-          <p:cNvPr id="39" name="TextBox 38"/>
-          <p:cNvSpPr txBox="1"/>
-          <p:nvPr/>
-        </p:nvSpPr>
-        <p:spPr>
-          <a:xfrm>
-            <a:off x="9829800" y="3950208"/>
-            <a:ext cx="1097280" cy="228600"/>
-          </a:xfrm>
-          <a:prstGeom prst="rect">
-            <a:avLst/>
-          </a:prstGeom>
-          <a:noFill/>
-        </p:spPr>
-        <p:txBody>
-          <a:bodyPr wrap="square" anchor="t">
-            <a:spAutoFit/>
-          </a:bodyPr>
-          <a:lstStyle/>
-          <a:p>
-            <a:pPr algn="ctr"/>
-            <a:r>
-              <a:rPr sz="900" b="1">
-                <a:solidFill>
-                  <a:srgbClr val="FFFFFF"/>
-                </a:solidFill>
-                <a:latin typeface="Segoe UI"/>
-              </a:rPr>
-              <a:t>Lines</a:t>
-            </a:r>
-          </a:p>
-        </p:txBody>
-      </p:sp>
-      <p:sp>
-        <p:nvSpPr>
-          <p:cNvPr id="40" name="TextBox 39"/>
-          <p:cNvSpPr txBox="1"/>
-          <p:nvPr/>
-        </p:nvSpPr>
-        <p:spPr>
-          <a:xfrm>
-            <a:off x="10927080" y="3950208"/>
-            <a:ext cx="548640" cy="228600"/>
-          </a:xfrm>
-          <a:prstGeom prst="rect">
-            <a:avLst/>
-          </a:prstGeom>
-          <a:noFill/>
-        </p:spPr>
-        <p:txBody>
-          <a:bodyPr wrap="square" anchor="t">
-            <a:spAutoFit/>
-          </a:bodyPr>
-          <a:lstStyle/>
-          <a:p>
-            <a:pPr algn="ctr"/>
-            <a:r>
-              <a:rPr sz="900" b="1">
-                <a:solidFill>
-                  <a:srgbClr val="FFFFFF"/>
-                </a:solidFill>
-                <a:latin typeface="Segoe UI"/>
-              </a:rPr>
-              <a:t>%</a:t>
-            </a:r>
-          </a:p>
-        </p:txBody>
-      </p:sp>
-      <p:sp>
-        <p:nvSpPr>
-          <p:cNvPr id="41" name="Rectangle 40"/>
-          <p:cNvSpPr/>
-          <p:nvPr/>
-        </p:nvSpPr>
-        <p:spPr>
-          <a:xfrm>
-            <a:off x="7132320" y="4206240"/>
-            <a:ext cx="4754880" cy="256032"/>
-          </a:xfrm>
-          <a:prstGeom prst="rect">
-            <a:avLst/>
-          </a:prstGeom>
-          <a:solidFill>
-            <a:srgbClr val="F8F9FA"/>
-          </a:solidFill>
-          <a:ln>
-            <a:noFill/>
-          </a:ln>
-        </p:spPr>
-        <p:style>
-          <a:lnRef idx="1">
-            <a:schemeClr val="accent1"/>
-          </a:lnRef>
-          <a:fillRef idx="3">
-            <a:schemeClr val="accent1"/>
-          </a:fillRef>
-          <a:effectRef idx="2">
-            <a:schemeClr val="accent1"/>
-          </a:effectRef>
-          <a:fontRef idx="minor">
-            <a:schemeClr val="lt1"/>
-          </a:fontRef>
-        </p:style>
-        <p:txBody>
-          <a:bodyPr rtlCol="0" anchor="ctr"/>
-          <a:lstStyle/>
-          <a:p>
-            <a:pPr algn="ctr"/>
-            <a:endParaRPr/>
-          </a:p>
-        </p:txBody>
-      </p:sp>
-      <p:sp>
-        <p:nvSpPr>
-          <p:cNvPr id="42" name="Oval 41"/>
-          <p:cNvSpPr/>
-          <p:nvPr/>
-        </p:nvSpPr>
-        <p:spPr>
-          <a:xfrm>
-            <a:off x="7223760" y="4279392"/>
-            <a:ext cx="109728" cy="109728"/>
-          </a:xfrm>
-          <a:prstGeom prst="ellipse">
-            <a:avLst/>
-          </a:prstGeom>
-          <a:solidFill>
-            <a:srgbClr val="FD7E14"/>
-          </a:solidFill>
-          <a:ln>
-            <a:noFill/>
-          </a:ln>
-        </p:spPr>
-        <p:style>
-          <a:lnRef idx="1">
-            <a:schemeClr val="accent1"/>
-          </a:lnRef>
-          <a:fillRef idx="3">
-            <a:schemeClr val="accent1"/>
-          </a:fillRef>
-          <a:effectRef idx="2">
-            <a:schemeClr val="accent1"/>
-          </a:effectRef>
-          <a:fontRef idx="minor">
-            <a:schemeClr val="lt1"/>
-          </a:fontRef>
-        </p:style>
-        <p:txBody>
-          <a:bodyPr rtlCol="0" anchor="ctr"/>
-          <a:lstStyle/>
-          <a:p>
-            <a:pPr algn="ctr"/>
-            <a:endParaRPr/>
-          </a:p>
-        </p:txBody>
-      </p:sp>
-      <p:sp>
-        <p:nvSpPr>
-          <p:cNvPr id="43" name="TextBox 42"/>
-          <p:cNvSpPr txBox="1"/>
-          <p:nvPr/>
-        </p:nvSpPr>
-        <p:spPr>
-          <a:xfrm>
-            <a:off x="7406640" y="4215384"/>
-            <a:ext cx="1554480" cy="228600"/>
-          </a:xfrm>
-          <a:prstGeom prst="rect">
-            <a:avLst/>
-          </a:prstGeom>
-          <a:noFill/>
-        </p:spPr>
-        <p:txBody>
-          <a:bodyPr wrap="square" anchor="t">
-            <a:spAutoFit/>
-          </a:bodyPr>
-          <a:lstStyle/>
-          <a:p>
-            <a:pPr algn="l"/>
-            <a:r>
-              <a:rPr sz="900" b="1">
-                <a:solidFill>
-                  <a:srgbClr val="1A1A2E"/>
-                </a:solidFill>
-                <a:latin typeface="Segoe UI"/>
-              </a:rPr>
-              <a:t>SQL (Snowflake)</a:t>
-            </a:r>
-          </a:p>
-        </p:txBody>
-      </p:sp>
-      <p:sp>
-        <p:nvSpPr>
-          <p:cNvPr id="44" name="TextBox 43"/>
-          <p:cNvSpPr txBox="1"/>
-          <p:nvPr/>
-        </p:nvSpPr>
-        <p:spPr>
-          <a:xfrm>
-            <a:off x="9006840" y="4215384"/>
-            <a:ext cx="822960" cy="228600"/>
-          </a:xfrm>
-          <a:prstGeom prst="rect">
-            <a:avLst/>
-          </a:prstGeom>
-          <a:noFill/>
-        </p:spPr>
-        <p:txBody>
-          <a:bodyPr wrap="square" anchor="t">
-            <a:spAutoFit/>
-          </a:bodyPr>
-          <a:lstStyle/>
-          <a:p>
-            <a:pPr algn="ctr"/>
-            <a:r>
-              <a:rPr sz="900" b="0">
-                <a:solidFill>
-                  <a:srgbClr val="6C757D"/>
-                </a:solidFill>
-                <a:latin typeface="Segoe UI"/>
-              </a:rPr>
-              <a:t>163 files</a:t>
-            </a:r>
-          </a:p>
-        </p:txBody>
-      </p:sp>
-      <p:sp>
-        <p:nvSpPr>
-          <p:cNvPr id="45" name="TextBox 44"/>
-          <p:cNvSpPr txBox="1"/>
-          <p:nvPr/>
-        </p:nvSpPr>
-        <p:spPr>
-          <a:xfrm>
-            <a:off x="9829800" y="4215384"/>
-            <a:ext cx="1097280" cy="228600"/>
-          </a:xfrm>
-          <a:prstGeom prst="rect">
-            <a:avLst/>
-          </a:prstGeom>
-          <a:noFill/>
-        </p:spPr>
-        <p:txBody>
-          <a:bodyPr wrap="square" anchor="t">
-            <a:spAutoFit/>
-          </a:bodyPr>
-          <a:lstStyle/>
-          <a:p>
-            <a:pPr algn="ctr"/>
-            <a:r>
-              <a:rPr sz="900" b="1">
-                <a:solidFill>
-                  <a:srgbClr val="1A1A2E"/>
-                </a:solidFill>
-                <a:latin typeface="Segoe UI"/>
-              </a:rPr>
-              <a:t>26,900 lines</a:t>
-            </a:r>
-          </a:p>
-        </p:txBody>
-      </p:sp>
-      <p:sp>
-        <p:nvSpPr>
-          <p:cNvPr id="46" name="TextBox 45"/>
-          <p:cNvSpPr txBox="1"/>
-          <p:nvPr/>
-        </p:nvSpPr>
-        <p:spPr>
-          <a:xfrm>
-            <a:off x="10927080" y="4215384"/>
-            <a:ext cx="548640" cy="228600"/>
-          </a:xfrm>
-          <a:prstGeom prst="rect">
-            <a:avLst/>
-          </a:prstGeom>
-          <a:noFill/>
-        </p:spPr>
-        <p:txBody>
-          <a:bodyPr wrap="square" anchor="t">
-            <a:spAutoFit/>
-          </a:bodyPr>
-          <a:lstStyle/>
-          <a:p>
-            <a:pPr algn="ctr"/>
-            <a:r>
-              <a:rPr sz="900" b="0">
-                <a:solidFill>
-                  <a:srgbClr val="6C757D"/>
-                </a:solidFill>
-                <a:latin typeface="Segoe UI"/>
-              </a:rPr>
-              <a:t>41%</a:t>
-            </a:r>
-          </a:p>
-        </p:txBody>
-      </p:sp>
-      <p:sp>
-        <p:nvSpPr>
-          <p:cNvPr id="47" name="Rectangle 46"/>
-          <p:cNvSpPr/>
-          <p:nvPr/>
-        </p:nvSpPr>
-        <p:spPr>
-          <a:xfrm>
-            <a:off x="7132320" y="4462272"/>
-            <a:ext cx="4754880" cy="256032"/>
-          </a:xfrm>
-          <a:prstGeom prst="rect">
-            <a:avLst/>
-          </a:prstGeom>
-          <a:solidFill>
-            <a:srgbClr val="FFFFFF"/>
-          </a:solidFill>
-          <a:ln>
-            <a:noFill/>
-          </a:ln>
-        </p:spPr>
-        <p:style>
-          <a:lnRef idx="1">
-            <a:schemeClr val="accent1"/>
-          </a:lnRef>
-          <a:fillRef idx="3">
-            <a:schemeClr val="accent1"/>
-          </a:fillRef>
-          <a:effectRef idx="2">
-            <a:schemeClr val="accent1"/>
-          </a:effectRef>
-          <a:fontRef idx="minor">
-            <a:schemeClr val="lt1"/>
-          </a:fontRef>
-        </p:style>
-        <p:txBody>
-          <a:bodyPr rtlCol="0" anchor="ctr"/>
-          <a:lstStyle/>
-          <a:p>
-            <a:pPr algn="ctr"/>
-            <a:endParaRPr/>
-          </a:p>
-        </p:txBody>
-      </p:sp>
-      <p:sp>
-        <p:nvSpPr>
-          <p:cNvPr id="48" name="Oval 47"/>
-          <p:cNvSpPr/>
-          <p:nvPr/>
-        </p:nvSpPr>
-        <p:spPr>
-          <a:xfrm>
-            <a:off x="7223760" y="4535424"/>
-            <a:ext cx="109728" cy="109728"/>
-          </a:xfrm>
-          <a:prstGeom prst="ellipse">
-            <a:avLst/>
-          </a:prstGeom>
-          <a:solidFill>
-            <a:srgbClr val="0D6EFD"/>
-          </a:solidFill>
-          <a:ln>
-            <a:noFill/>
-          </a:ln>
-        </p:spPr>
-        <p:style>
-          <a:lnRef idx="1">
-            <a:schemeClr val="accent1"/>
-          </a:lnRef>
-          <a:fillRef idx="3">
-            <a:schemeClr val="accent1"/>
-          </a:fillRef>
-          <a:effectRef idx="2">
-            <a:schemeClr val="accent1"/>
-          </a:effectRef>
-          <a:fontRef idx="minor">
-            <a:schemeClr val="lt1"/>
-          </a:fontRef>
-        </p:style>
-        <p:txBody>
-          <a:bodyPr rtlCol="0" anchor="ctr"/>
-          <a:lstStyle/>
-          <a:p>
-            <a:pPr algn="ctr"/>
-            <a:endParaRPr/>
-          </a:p>
-        </p:txBody>
-      </p:sp>
-      <p:sp>
-        <p:nvSpPr>
-          <p:cNvPr id="49" name="TextBox 48"/>
-          <p:cNvSpPr txBox="1"/>
-          <p:nvPr/>
-        </p:nvSpPr>
-        <p:spPr>
-          <a:xfrm>
-            <a:off x="7406640" y="4471416"/>
-            <a:ext cx="1554480" cy="228600"/>
-          </a:xfrm>
-          <a:prstGeom prst="rect">
-            <a:avLst/>
-          </a:prstGeom>
-          <a:noFill/>
-        </p:spPr>
-        <p:txBody>
-          <a:bodyPr wrap="square" anchor="t">
-            <a:spAutoFit/>
-          </a:bodyPr>
-          <a:lstStyle/>
-          <a:p>
-            <a:pPr algn="l"/>
-            <a:r>
-              <a:rPr sz="900" b="1">
-                <a:solidFill>
-                  <a:srgbClr val="1A1A2E"/>
-                </a:solidFill>
-                <a:latin typeface="Segoe UI"/>
-              </a:rPr>
-              <a:t>React (JSX/CSS/JS)</a:t>
-            </a:r>
-          </a:p>
-        </p:txBody>
-      </p:sp>
-      <p:sp>
-        <p:nvSpPr>
-          <p:cNvPr id="50" name="TextBox 49"/>
-          <p:cNvSpPr txBox="1"/>
-          <p:nvPr/>
-        </p:nvSpPr>
-        <p:spPr>
-          <a:xfrm>
-            <a:off x="9006840" y="4471416"/>
-            <a:ext cx="822960" cy="228600"/>
-          </a:xfrm>
-          <a:prstGeom prst="rect">
-            <a:avLst/>
-          </a:prstGeom>
-          <a:noFill/>
-        </p:spPr>
-        <p:txBody>
-          <a:bodyPr wrap="square" anchor="t">
-            <a:spAutoFit/>
-          </a:bodyPr>
-          <a:lstStyle/>
-          <a:p>
-            <a:pPr algn="ctr"/>
-            <a:r>
-              <a:rPr sz="900" b="0">
-                <a:solidFill>
-                  <a:srgbClr val="6C757D"/>
-                </a:solidFill>
-                <a:latin typeface="Segoe UI"/>
-              </a:rPr>
-              <a:t>68 files</a:t>
-            </a:r>
-          </a:p>
-        </p:txBody>
-      </p:sp>
-      <p:sp>
-        <p:nvSpPr>
-          <p:cNvPr id="51" name="TextBox 50"/>
-          <p:cNvSpPr txBox="1"/>
-          <p:nvPr/>
-        </p:nvSpPr>
-        <p:spPr>
-          <a:xfrm>
-            <a:off x="9829800" y="4471416"/>
-            <a:ext cx="1097280" cy="228600"/>
-          </a:xfrm>
-          <a:prstGeom prst="rect">
-            <a:avLst/>
-          </a:prstGeom>
-          <a:noFill/>
-        </p:spPr>
-        <p:txBody>
-          <a:bodyPr wrap="square" anchor="t">
-            <a:spAutoFit/>
-          </a:bodyPr>
-          <a:lstStyle/>
-          <a:p>
-            <a:pPr algn="ctr"/>
-            <a:r>
-              <a:rPr sz="900" b="1">
-                <a:solidFill>
-                  <a:srgbClr val="1A1A2E"/>
-                </a:solidFill>
-                <a:latin typeface="Segoe UI"/>
-              </a:rPr>
-              <a:t>21,700 lines</a:t>
-            </a:r>
-          </a:p>
-        </p:txBody>
-      </p:sp>
-      <p:sp>
-        <p:nvSpPr>
-          <p:cNvPr id="52" name="TextBox 51"/>
-          <p:cNvSpPr txBox="1"/>
-          <p:nvPr/>
-        </p:nvSpPr>
-        <p:spPr>
-          <a:xfrm>
-            <a:off x="10927080" y="4471416"/>
-            <a:ext cx="548640" cy="228600"/>
-          </a:xfrm>
-          <a:prstGeom prst="rect">
-            <a:avLst/>
-          </a:prstGeom>
-          <a:noFill/>
-        </p:spPr>
-        <p:txBody>
-          <a:bodyPr wrap="square" anchor="t">
-            <a:spAutoFit/>
-          </a:bodyPr>
-          <a:lstStyle/>
-          <a:p>
-            <a:pPr algn="ctr"/>
-            <a:r>
-              <a:rPr sz="900" b="0">
-                <a:solidFill>
-                  <a:srgbClr val="6C757D"/>
-                </a:solidFill>
-                <a:latin typeface="Segoe UI"/>
-              </a:rPr>
-              <a:t>33%</a:t>
-            </a:r>
-          </a:p>
-        </p:txBody>
-      </p:sp>
-      <p:sp>
-        <p:nvSpPr>
-          <p:cNvPr id="53" name="Rectangle 52"/>
-          <p:cNvSpPr/>
-          <p:nvPr/>
-        </p:nvSpPr>
-        <p:spPr>
-          <a:xfrm>
-            <a:off x="7132320" y="4718304"/>
-            <a:ext cx="4754880" cy="256032"/>
-          </a:xfrm>
-          <a:prstGeom prst="rect">
-            <a:avLst/>
-          </a:prstGeom>
-          <a:solidFill>
-            <a:srgbClr val="F8F9FA"/>
-          </a:solidFill>
-          <a:ln>
-            <a:noFill/>
-          </a:ln>
-        </p:spPr>
-        <p:style>
-          <a:lnRef idx="1">
-            <a:schemeClr val="accent1"/>
-          </a:lnRef>
-          <a:fillRef idx="3">
-            <a:schemeClr val="accent1"/>
-          </a:fillRef>
-          <a:effectRef idx="2">
-            <a:schemeClr val="accent1"/>
-          </a:effectRef>
-          <a:fontRef idx="minor">
-            <a:schemeClr val="lt1"/>
-          </a:fontRef>
-        </p:style>
-        <p:txBody>
-          <a:bodyPr rtlCol="0" anchor="ctr"/>
-          <a:lstStyle/>
-          <a:p>
-            <a:pPr algn="ctr"/>
-            <a:endParaRPr/>
-          </a:p>
-        </p:txBody>
-      </p:sp>
-      <p:sp>
-        <p:nvSpPr>
-          <p:cNvPr id="54" name="Oval 53"/>
-          <p:cNvSpPr/>
-          <p:nvPr/>
-        </p:nvSpPr>
-        <p:spPr>
-          <a:xfrm>
-            <a:off x="7223760" y="4791456"/>
-            <a:ext cx="109728" cy="109728"/>
-          </a:xfrm>
-          <a:prstGeom prst="ellipse">
-            <a:avLst/>
-          </a:prstGeom>
-          <a:solidFill>
-            <a:srgbClr val="20C997"/>
-          </a:solidFill>
-          <a:ln>
-            <a:noFill/>
-          </a:ln>
-        </p:spPr>
-        <p:style>
-          <a:lnRef idx="1">
-            <a:schemeClr val="accent1"/>
-          </a:lnRef>
-          <a:fillRef idx="3">
-            <a:schemeClr val="accent1"/>
-          </a:fillRef>
-          <a:effectRef idx="2">
-            <a:schemeClr val="accent1"/>
-          </a:effectRef>
-          <a:fontRef idx="minor">
-            <a:schemeClr val="lt1"/>
-          </a:fontRef>
-        </p:style>
-        <p:txBody>
-          <a:bodyPr rtlCol="0" anchor="ctr"/>
-          <a:lstStyle/>
-          <a:p>
-            <a:pPr algn="ctr"/>
-            <a:endParaRPr/>
-          </a:p>
-        </p:txBody>
-      </p:sp>
-      <p:sp>
-        <p:nvSpPr>
-          <p:cNvPr id="55" name="TextBox 54"/>
-          <p:cNvSpPr txBox="1"/>
-          <p:nvPr/>
-        </p:nvSpPr>
-        <p:spPr>
-          <a:xfrm>
-            <a:off x="7406640" y="4727448"/>
-            <a:ext cx="1554480" cy="228600"/>
-          </a:xfrm>
-          <a:prstGeom prst="rect">
-            <a:avLst/>
-          </a:prstGeom>
-          <a:noFill/>
-        </p:spPr>
-        <p:txBody>
-          <a:bodyPr wrap="square" anchor="t">
-            <a:spAutoFit/>
-          </a:bodyPr>
-          <a:lstStyle/>
-          <a:p>
-            <a:pPr algn="l"/>
-            <a:r>
-              <a:rPr sz="900" b="1">
-                <a:solidFill>
-                  <a:srgbClr val="1A1A2E"/>
-                </a:solidFill>
-                <a:latin typeface="Segoe UI"/>
-              </a:rPr>
-              <a:t>Python (FastAPI)</a:t>
-            </a:r>
-          </a:p>
-        </p:txBody>
-      </p:sp>
-      <p:sp>
-        <p:nvSpPr>
-          <p:cNvPr id="56" name="TextBox 55"/>
-          <p:cNvSpPr txBox="1"/>
-          <p:nvPr/>
-        </p:nvSpPr>
-        <p:spPr>
-          <a:xfrm>
-            <a:off x="9006840" y="4727448"/>
-            <a:ext cx="822960" cy="228600"/>
-          </a:xfrm>
-          <a:prstGeom prst="rect">
-            <a:avLst/>
-          </a:prstGeom>
-          <a:noFill/>
-        </p:spPr>
-        <p:txBody>
-          <a:bodyPr wrap="square" anchor="t">
-            <a:spAutoFit/>
-          </a:bodyPr>
-          <a:lstStyle/>
-          <a:p>
-            <a:pPr algn="ctr"/>
-            <a:r>
-              <a:rPr sz="900" b="0">
-                <a:solidFill>
-                  <a:srgbClr val="6C757D"/>
-                </a:solidFill>
-                <a:latin typeface="Segoe UI"/>
-              </a:rPr>
-              <a:t>27 files</a:t>
-            </a:r>
-          </a:p>
-        </p:txBody>
-      </p:sp>
-      <p:sp>
-        <p:nvSpPr>
-          <p:cNvPr id="57" name="TextBox 56"/>
-          <p:cNvSpPr txBox="1"/>
-          <p:nvPr/>
-        </p:nvSpPr>
-        <p:spPr>
-          <a:xfrm>
-            <a:off x="9829800" y="4727448"/>
-            <a:ext cx="1097280" cy="228600"/>
-          </a:xfrm>
-          <a:prstGeom prst="rect">
-            <a:avLst/>
-          </a:prstGeom>
-          <a:noFill/>
-        </p:spPr>
-        <p:txBody>
-          <a:bodyPr wrap="square" anchor="t">
-            <a:spAutoFit/>
-          </a:bodyPr>
-          <a:lstStyle/>
-          <a:p>
-            <a:pPr algn="ctr"/>
-            <a:r>
-              <a:rPr sz="900" b="1">
-                <a:solidFill>
-                  <a:srgbClr val="1A1A2E"/>
-                </a:solidFill>
-                <a:latin typeface="Segoe UI"/>
-              </a:rPr>
-              <a:t>8,500 lines</a:t>
-            </a:r>
-          </a:p>
-        </p:txBody>
-      </p:sp>
-      <p:sp>
-        <p:nvSpPr>
-          <p:cNvPr id="58" name="TextBox 57"/>
-          <p:cNvSpPr txBox="1"/>
-          <p:nvPr/>
-        </p:nvSpPr>
-        <p:spPr>
-          <a:xfrm>
-            <a:off x="10927080" y="4727448"/>
-            <a:ext cx="548640" cy="228600"/>
-          </a:xfrm>
-          <a:prstGeom prst="rect">
-            <a:avLst/>
-          </a:prstGeom>
-          <a:noFill/>
-        </p:spPr>
-        <p:txBody>
-          <a:bodyPr wrap="square" anchor="t">
-            <a:spAutoFit/>
-          </a:bodyPr>
-          <a:lstStyle/>
-          <a:p>
-            <a:pPr algn="ctr"/>
-            <a:r>
-              <a:rPr sz="900" b="0">
-                <a:solidFill>
-                  <a:srgbClr val="6C757D"/>
-                </a:solidFill>
-                <a:latin typeface="Segoe UI"/>
-              </a:rPr>
-              <a:t>13%</a:t>
-            </a:r>
-          </a:p>
-        </p:txBody>
-      </p:sp>
-      <p:sp>
-        <p:nvSpPr>
-          <p:cNvPr id="59" name="Rectangle 58"/>
-          <p:cNvSpPr/>
-          <p:nvPr/>
-        </p:nvSpPr>
-        <p:spPr>
-          <a:xfrm>
-            <a:off x="7132320" y="4974336"/>
-            <a:ext cx="4754880" cy="256032"/>
-          </a:xfrm>
-          <a:prstGeom prst="rect">
-            <a:avLst/>
-          </a:prstGeom>
-          <a:solidFill>
-            <a:srgbClr val="FFFFFF"/>
-          </a:solidFill>
-          <a:ln>
-            <a:noFill/>
-          </a:ln>
-        </p:spPr>
-        <p:style>
-          <a:lnRef idx="1">
-            <a:schemeClr val="accent1"/>
-          </a:lnRef>
-          <a:fillRef idx="3">
-            <a:schemeClr val="accent1"/>
-          </a:fillRef>
-          <a:effectRef idx="2">
-            <a:schemeClr val="accent1"/>
-          </a:effectRef>
-          <a:fontRef idx="minor">
-            <a:schemeClr val="lt1"/>
-          </a:fontRef>
-        </p:style>
-        <p:txBody>
-          <a:bodyPr rtlCol="0" anchor="ctr"/>
-          <a:lstStyle/>
-          <a:p>
-            <a:pPr algn="ctr"/>
-            <a:endParaRPr/>
-          </a:p>
-        </p:txBody>
-      </p:sp>
-      <p:sp>
-        <p:nvSpPr>
-          <p:cNvPr id="60" name="Oval 59"/>
-          <p:cNvSpPr/>
-          <p:nvPr/>
-        </p:nvSpPr>
-        <p:spPr>
-          <a:xfrm>
-            <a:off x="7223760" y="5047488"/>
-            <a:ext cx="109728" cy="109728"/>
-          </a:xfrm>
-          <a:prstGeom prst="ellipse">
-            <a:avLst/>
-          </a:prstGeom>
-          <a:solidFill>
-            <a:srgbClr val="6F42C1"/>
-          </a:solidFill>
-          <a:ln>
-            <a:noFill/>
-          </a:ln>
-        </p:spPr>
-        <p:style>
-          <a:lnRef idx="1">
-            <a:schemeClr val="accent1"/>
-          </a:lnRef>
-          <a:fillRef idx="3">
-            <a:schemeClr val="accent1"/>
-          </a:fillRef>
-          <a:effectRef idx="2">
-            <a:schemeClr val="accent1"/>
-          </a:effectRef>
-          <a:fontRef idx="minor">
-            <a:schemeClr val="lt1"/>
-          </a:fontRef>
-        </p:style>
-        <p:txBody>
-          <a:bodyPr rtlCol="0" anchor="ctr"/>
-          <a:lstStyle/>
-          <a:p>
-            <a:pPr algn="ctr"/>
-            <a:endParaRPr/>
-          </a:p>
-        </p:txBody>
-      </p:sp>
-      <p:sp>
-        <p:nvSpPr>
-          <p:cNvPr id="61" name="TextBox 60"/>
-          <p:cNvSpPr txBox="1"/>
-          <p:nvPr/>
-        </p:nvSpPr>
-        <p:spPr>
-          <a:xfrm>
-            <a:off x="7406640" y="4983480"/>
-            <a:ext cx="1554480" cy="228600"/>
-          </a:xfrm>
-          <a:prstGeom prst="rect">
-            <a:avLst/>
-          </a:prstGeom>
-          <a:noFill/>
-        </p:spPr>
-        <p:txBody>
-          <a:bodyPr wrap="square" anchor="t">
-            <a:spAutoFit/>
-          </a:bodyPr>
-          <a:lstStyle/>
-          <a:p>
-            <a:pPr algn="l"/>
-            <a:r>
-              <a:rPr sz="900" b="1">
-                <a:solidFill>
-                  <a:srgbClr val="1A1A2E"/>
-                </a:solidFill>
-                <a:latin typeface="Segoe UI"/>
-              </a:rPr>
-              <a:t>Python (Scripts)</a:t>
-            </a:r>
-          </a:p>
-        </p:txBody>
-      </p:sp>
-      <p:sp>
-        <p:nvSpPr>
-          <p:cNvPr id="62" name="TextBox 61"/>
-          <p:cNvSpPr txBox="1"/>
-          <p:nvPr/>
-        </p:nvSpPr>
-        <p:spPr>
-          <a:xfrm>
-            <a:off x="9006840" y="4983480"/>
-            <a:ext cx="822960" cy="228600"/>
-          </a:xfrm>
-          <a:prstGeom prst="rect">
-            <a:avLst/>
-          </a:prstGeom>
-          <a:noFill/>
-        </p:spPr>
-        <p:txBody>
-          <a:bodyPr wrap="square" anchor="t">
-            <a:spAutoFit/>
-          </a:bodyPr>
-          <a:lstStyle/>
-          <a:p>
-            <a:pPr algn="ctr"/>
-            <a:r>
-              <a:rPr sz="900" b="0">
-                <a:solidFill>
-                  <a:srgbClr val="6C757D"/>
-                </a:solidFill>
-                <a:latin typeface="Segoe UI"/>
-              </a:rPr>
-              <a:t>6 files</a:t>
-            </a:r>
-          </a:p>
-        </p:txBody>
-      </p:sp>
-      <p:sp>
-        <p:nvSpPr>
-          <p:cNvPr id="63" name="TextBox 62"/>
-          <p:cNvSpPr txBox="1"/>
-          <p:nvPr/>
-        </p:nvSpPr>
-        <p:spPr>
-          <a:xfrm>
-            <a:off x="9829800" y="4983480"/>
-            <a:ext cx="1097280" cy="228600"/>
-          </a:xfrm>
-          <a:prstGeom prst="rect">
-            <a:avLst/>
-          </a:prstGeom>
-          <a:noFill/>
-        </p:spPr>
-        <p:txBody>
-          <a:bodyPr wrap="square" anchor="t">
-            <a:spAutoFit/>
-          </a:bodyPr>
-          <a:lstStyle/>
-          <a:p>
-            <a:pPr algn="ctr"/>
-            <a:r>
-              <a:rPr sz="900" b="1">
-                <a:solidFill>
-                  <a:srgbClr val="1A1A2E"/>
-                </a:solidFill>
-                <a:latin typeface="Segoe UI"/>
-              </a:rPr>
-              <a:t>3,900 lines</a:t>
-            </a:r>
-          </a:p>
-        </p:txBody>
-      </p:sp>
-      <p:sp>
-        <p:nvSpPr>
-          <p:cNvPr id="64" name="TextBox 63"/>
-          <p:cNvSpPr txBox="1"/>
-          <p:nvPr/>
-        </p:nvSpPr>
-        <p:spPr>
-          <a:xfrm>
-            <a:off x="10927080" y="4983480"/>
-            <a:ext cx="548640" cy="228600"/>
-          </a:xfrm>
-          <a:prstGeom prst="rect">
-            <a:avLst/>
-          </a:prstGeom>
-          <a:noFill/>
-        </p:spPr>
-        <p:txBody>
-          <a:bodyPr wrap="square" anchor="t">
-            <a:spAutoFit/>
-          </a:bodyPr>
-          <a:lstStyle/>
-          <a:p>
-            <a:pPr algn="ctr"/>
-            <a:r>
-              <a:rPr sz="900" b="0">
-                <a:solidFill>
-                  <a:srgbClr val="6C757D"/>
-                </a:solidFill>
-                <a:latin typeface="Segoe UI"/>
-              </a:rPr>
-              <a:t>6%</a:t>
-            </a:r>
-          </a:p>
-        </p:txBody>
-      </p:sp>
-      <p:sp>
-        <p:nvSpPr>
-          <p:cNvPr id="65" name="Rectangle 64"/>
-          <p:cNvSpPr/>
-          <p:nvPr/>
-        </p:nvSpPr>
-        <p:spPr>
-          <a:xfrm>
-            <a:off x="7132320" y="5230368"/>
-            <a:ext cx="4754880" cy="256032"/>
-          </a:xfrm>
-          <a:prstGeom prst="rect">
-            <a:avLst/>
-          </a:prstGeom>
-          <a:solidFill>
-            <a:srgbClr val="F8F9FA"/>
-          </a:solidFill>
-          <a:ln>
-            <a:noFill/>
-          </a:ln>
-        </p:spPr>
-        <p:style>
-          <a:lnRef idx="1">
-            <a:schemeClr val="accent1"/>
-          </a:lnRef>
-          <a:fillRef idx="3">
-            <a:schemeClr val="accent1"/>
-          </a:fillRef>
-          <a:effectRef idx="2">
-            <a:schemeClr val="accent1"/>
-          </a:effectRef>
-          <a:fontRef idx="minor">
-            <a:schemeClr val="lt1"/>
-          </a:fontRef>
-        </p:style>
-        <p:txBody>
-          <a:bodyPr rtlCol="0" anchor="ctr"/>
-          <a:lstStyle/>
-          <a:p>
-            <a:pPr algn="ctr"/>
-            <a:endParaRPr/>
-          </a:p>
-        </p:txBody>
-      </p:sp>
-      <p:sp>
-        <p:nvSpPr>
-          <p:cNvPr id="66" name="Oval 65"/>
-          <p:cNvSpPr/>
-          <p:nvPr/>
-        </p:nvSpPr>
-        <p:spPr>
-          <a:xfrm>
-            <a:off x="7223760" y="5303520"/>
-            <a:ext cx="109728" cy="109728"/>
-          </a:xfrm>
-          <a:prstGeom prst="ellipse">
-            <a:avLst/>
-          </a:prstGeom>
-          <a:solidFill>
-            <a:srgbClr val="6C757D"/>
-          </a:solidFill>
-          <a:ln>
-            <a:noFill/>
-          </a:ln>
-        </p:spPr>
-        <p:style>
-          <a:lnRef idx="1">
-            <a:schemeClr val="accent1"/>
-          </a:lnRef>
-          <a:fillRef idx="3">
-            <a:schemeClr val="accent1"/>
-          </a:fillRef>
-          <a:effectRef idx="2">
-            <a:schemeClr val="accent1"/>
-          </a:effectRef>
-          <a:fontRef idx="minor">
-            <a:schemeClr val="lt1"/>
-          </a:fontRef>
-        </p:style>
-        <p:txBody>
-          <a:bodyPr rtlCol="0" anchor="ctr"/>
-          <a:lstStyle/>
-          <a:p>
-            <a:pPr algn="ctr"/>
-            <a:endParaRPr/>
-          </a:p>
-        </p:txBody>
-      </p:sp>
-      <p:sp>
-        <p:nvSpPr>
-          <p:cNvPr id="67" name="TextBox 66"/>
-          <p:cNvSpPr txBox="1"/>
-          <p:nvPr/>
-        </p:nvSpPr>
-        <p:spPr>
-          <a:xfrm>
-            <a:off x="7406640" y="5239512"/>
-            <a:ext cx="1554480" cy="228600"/>
-          </a:xfrm>
-          <a:prstGeom prst="rect">
-            <a:avLst/>
-          </a:prstGeom>
-          <a:noFill/>
-        </p:spPr>
-        <p:txBody>
-          <a:bodyPr wrap="square" anchor="t">
-            <a:spAutoFit/>
-          </a:bodyPr>
-          <a:lstStyle/>
-          <a:p>
-            <a:pPr algn="l"/>
-            <a:r>
-              <a:rPr sz="900" b="1">
-                <a:solidFill>
-                  <a:srgbClr val="1A1A2E"/>
-                </a:solidFill>
-                <a:latin typeface="Segoe UI"/>
-              </a:rPr>
-              <a:t>Documentation</a:t>
-            </a:r>
-          </a:p>
-        </p:txBody>
-      </p:sp>
-      <p:sp>
-        <p:nvSpPr>
-          <p:cNvPr id="68" name="TextBox 67"/>
-          <p:cNvSpPr txBox="1"/>
-          <p:nvPr/>
-        </p:nvSpPr>
-        <p:spPr>
-          <a:xfrm>
-            <a:off x="9006840" y="5239512"/>
-            <a:ext cx="822960" cy="228600"/>
-          </a:xfrm>
-          <a:prstGeom prst="rect">
-            <a:avLst/>
-          </a:prstGeom>
-          <a:noFill/>
-        </p:spPr>
-        <p:txBody>
-          <a:bodyPr wrap="square" anchor="t">
-            <a:spAutoFit/>
-          </a:bodyPr>
-          <a:lstStyle/>
-          <a:p>
-            <a:pPr algn="ctr"/>
-            <a:r>
-              <a:rPr sz="900" b="0">
-                <a:solidFill>
-                  <a:srgbClr val="6C757D"/>
-                </a:solidFill>
-                <a:latin typeface="Segoe UI"/>
-              </a:rPr>
-              <a:t>35 files</a:t>
-            </a:r>
-          </a:p>
-        </p:txBody>
-      </p:sp>
-      <p:sp>
-        <p:nvSpPr>
-          <p:cNvPr id="69" name="TextBox 68"/>
-          <p:cNvSpPr txBox="1"/>
-          <p:nvPr/>
-        </p:nvSpPr>
-        <p:spPr>
-          <a:xfrm>
-            <a:off x="9829800" y="5239512"/>
-            <a:ext cx="1097280" cy="228600"/>
-          </a:xfrm>
-          <a:prstGeom prst="rect">
-            <a:avLst/>
-          </a:prstGeom>
-          <a:noFill/>
-        </p:spPr>
-        <p:txBody>
-          <a:bodyPr wrap="square" anchor="t">
-            <a:spAutoFit/>
-          </a:bodyPr>
-          <a:lstStyle/>
-          <a:p>
-            <a:pPr algn="ctr"/>
-            <a:r>
-              <a:rPr sz="900" b="1">
-                <a:solidFill>
-                  <a:srgbClr val="1A1A2E"/>
-                </a:solidFill>
-                <a:latin typeface="Segoe UI"/>
-              </a:rPr>
-              <a:t>4,700 lines</a:t>
-            </a:r>
-          </a:p>
-        </p:txBody>
-      </p:sp>
-      <p:sp>
-        <p:nvSpPr>
-          <p:cNvPr id="70" name="TextBox 69"/>
-          <p:cNvSpPr txBox="1"/>
-          <p:nvPr/>
-        </p:nvSpPr>
-        <p:spPr>
-          <a:xfrm>
-            <a:off x="10927080" y="5239512"/>
-            <a:ext cx="548640" cy="228600"/>
-          </a:xfrm>
-          <a:prstGeom prst="rect">
-            <a:avLst/>
-          </a:prstGeom>
-          <a:noFill/>
-        </p:spPr>
-        <p:txBody>
-          <a:bodyPr wrap="square" anchor="t">
-            <a:spAutoFit/>
-          </a:bodyPr>
-          <a:lstStyle/>
-          <a:p>
-            <a:pPr algn="ctr"/>
-            <a:r>
-              <a:rPr sz="900" b="0">
-                <a:solidFill>
-                  <a:srgbClr val="6C757D"/>
-                </a:solidFill>
-                <a:latin typeface="Segoe UI"/>
-              </a:rPr>
-              <a:t>7%</a:t>
-            </a:r>
-          </a:p>
-        </p:txBody>
-      </p:sp>
-      <p:sp>
-        <p:nvSpPr>
-          <p:cNvPr id="71" name="Rectangle 70"/>
-          <p:cNvSpPr/>
-          <p:nvPr/>
-        </p:nvSpPr>
-        <p:spPr>
-          <a:xfrm>
-            <a:off x="7132320" y="5486400"/>
-            <a:ext cx="4754880" cy="274320"/>
-          </a:xfrm>
-          <a:prstGeom prst="rect">
-            <a:avLst/>
-          </a:prstGeom>
-          <a:solidFill>
-            <a:srgbClr val="0D1540"/>
-          </a:solidFill>
-          <a:ln>
-            <a:noFill/>
-          </a:ln>
-        </p:spPr>
-        <p:style>
-          <a:lnRef idx="1">
-            <a:schemeClr val="accent1"/>
-          </a:lnRef>
-          <a:fillRef idx="3">
-            <a:schemeClr val="accent1"/>
-          </a:fillRef>
-          <a:effectRef idx="2">
-            <a:schemeClr val="accent1"/>
-          </a:effectRef>
-          <a:fontRef idx="minor">
-            <a:schemeClr val="lt1"/>
-          </a:fontRef>
-        </p:style>
-        <p:txBody>
-          <a:bodyPr rtlCol="0" anchor="ctr"/>
-          <a:lstStyle/>
-          <a:p>
-            <a:pPr algn="ctr"/>
-            <a:endParaRPr/>
-          </a:p>
-        </p:txBody>
-      </p:sp>
-      <p:sp>
-        <p:nvSpPr>
-          <p:cNvPr id="72" name="TextBox 71"/>
-          <p:cNvSpPr txBox="1"/>
-          <p:nvPr/>
-        </p:nvSpPr>
-        <p:spPr>
-          <a:xfrm>
-            <a:off x="7406640" y="5504688"/>
-            <a:ext cx="1554480" cy="228600"/>
-          </a:xfrm>
-          <a:prstGeom prst="rect">
-            <a:avLst/>
-          </a:prstGeom>
-          <a:noFill/>
-        </p:spPr>
-        <p:txBody>
-          <a:bodyPr wrap="square" anchor="t">
-            <a:spAutoFit/>
-          </a:bodyPr>
-          <a:lstStyle/>
-          <a:p>
-            <a:pPr algn="l"/>
-            <a:r>
-              <a:rPr sz="900" b="1">
-                <a:solidFill>
-                  <a:srgbClr val="FFFFFF"/>
-                </a:solidFill>
-                <a:latin typeface="Segoe UI"/>
-              </a:rPr>
-              <a:t>TOTAL</a:t>
-            </a:r>
-          </a:p>
-        </p:txBody>
-      </p:sp>
-      <p:sp>
-        <p:nvSpPr>
-          <p:cNvPr id="73" name="TextBox 72"/>
-          <p:cNvSpPr txBox="1"/>
-          <p:nvPr/>
-        </p:nvSpPr>
-        <p:spPr>
-          <a:xfrm>
-            <a:off x="9006840" y="5504688"/>
-            <a:ext cx="822960" cy="228600"/>
-          </a:xfrm>
-          <a:prstGeom prst="rect">
-            <a:avLst/>
-          </a:prstGeom>
-          <a:noFill/>
-        </p:spPr>
-        <p:txBody>
-          <a:bodyPr wrap="square" anchor="t">
-            <a:spAutoFit/>
-          </a:bodyPr>
-          <a:lstStyle/>
-          <a:p>
-            <a:pPr algn="ctr"/>
-            <a:r>
-              <a:rPr sz="900" b="1">
-                <a:solidFill>
-                  <a:srgbClr val="4FC3F7"/>
-                </a:solidFill>
-                <a:latin typeface="Segoe UI"/>
-              </a:rPr>
-              <a:t>299</a:t>
-            </a:r>
-          </a:p>
-        </p:txBody>
-      </p:sp>
-      <p:sp>
-        <p:nvSpPr>
-          <p:cNvPr id="74" name="TextBox 73"/>
-          <p:cNvSpPr txBox="1"/>
-          <p:nvPr/>
-        </p:nvSpPr>
-        <p:spPr>
-          <a:xfrm>
-            <a:off x="9829800" y="5504688"/>
-            <a:ext cx="1097280" cy="228600"/>
-          </a:xfrm>
-          <a:prstGeom prst="rect">
-            <a:avLst/>
-          </a:prstGeom>
-          <a:noFill/>
-        </p:spPr>
-        <p:txBody>
-          <a:bodyPr wrap="square" anchor="t">
-            <a:spAutoFit/>
-          </a:bodyPr>
-          <a:lstStyle/>
-          <a:p>
-            <a:pPr algn="ctr"/>
-            <a:r>
-              <a:rPr sz="900" b="1">
-                <a:solidFill>
-                  <a:srgbClr val="4FC3F7"/>
-                </a:solidFill>
-                <a:latin typeface="Segoe UI"/>
-              </a:rPr>
-              <a:t>65,700</a:t>
-            </a:r>
-          </a:p>
-        </p:txBody>
-      </p:sp>
-      <p:sp>
-        <p:nvSpPr>
-          <p:cNvPr id="75" name="TextBox 74"/>
-          <p:cNvSpPr txBox="1"/>
-          <p:nvPr/>
-        </p:nvSpPr>
-        <p:spPr>
-          <a:xfrm>
-            <a:off x="10927080" y="5504688"/>
-            <a:ext cx="548640" cy="228600"/>
-          </a:xfrm>
-          <a:prstGeom prst="rect">
-            <a:avLst/>
-          </a:prstGeom>
-          <a:noFill/>
-        </p:spPr>
-        <p:txBody>
-          <a:bodyPr wrap="square" anchor="t">
-            <a:spAutoFit/>
-          </a:bodyPr>
-          <a:lstStyle/>
-          <a:p>
-            <a:pPr algn="ctr"/>
-            <a:r>
-              <a:rPr sz="900" b="1">
-                <a:solidFill>
-                  <a:srgbClr val="4FC3F7"/>
-                </a:solidFill>
-                <a:latin typeface="Segoe UI"/>
-              </a:rPr>
-              <a:t>100%</a:t>
-            </a:r>
-          </a:p>
-        </p:txBody>
-      </p:sp>
-      <p:sp>
-        <p:nvSpPr>
-          <p:cNvPr id="76" name="Rounded Rectangle 75"/>
-          <p:cNvSpPr/>
-          <p:nvPr/>
-        </p:nvSpPr>
-        <p:spPr>
-          <a:xfrm>
-            <a:off x="457200" y="5943600"/>
-            <a:ext cx="11247120" cy="731520"/>
-          </a:xfrm>
-          <a:prstGeom prst="roundRect">
-            <a:avLst/>
-          </a:prstGeom>
-          <a:solidFill>
-            <a:srgbClr val="E3F2FD"/>
-          </a:solidFill>
-          <a:ln>
-            <a:noFill/>
-          </a:ln>
-        </p:spPr>
-        <p:style>
-          <a:lnRef idx="1">
-            <a:schemeClr val="accent1"/>
-          </a:lnRef>
-          <a:fillRef idx="3">
-            <a:schemeClr val="accent1"/>
-          </a:fillRef>
-          <a:effectRef idx="2">
-            <a:schemeClr val="accent1"/>
-          </a:effectRef>
-          <a:fontRef idx="minor">
-            <a:schemeClr val="lt1"/>
-          </a:fontRef>
-        </p:style>
-        <p:txBody>
-          <a:bodyPr rtlCol="0" anchor="ctr"/>
-          <a:lstStyle/>
-          <a:p>
-            <a:pPr algn="ctr"/>
-            <a:endParaRPr/>
-          </a:p>
-        </p:txBody>
-      </p:sp>
-      <p:sp>
-        <p:nvSpPr>
-          <p:cNvPr id="77" name="TextBox 76"/>
-          <p:cNvSpPr txBox="1"/>
-          <p:nvPr/>
-        </p:nvSpPr>
-        <p:spPr>
-          <a:xfrm>
-            <a:off x="731520" y="5989320"/>
-            <a:ext cx="10789920" cy="523220"/>
-          </a:xfrm>
-          <a:prstGeom prst="rect">
-            <a:avLst/>
-          </a:prstGeom>
-          <a:noFill/>
-        </p:spPr>
-        <p:txBody>
-          <a:bodyPr wrap="square" anchor="t">
-            <a:spAutoFit/>
-          </a:bodyPr>
-          <a:lstStyle/>
-          <a:p>
-            <a:pPr algn="ctr"/>
-            <a:r>
-              <a:rPr sz="1400" b="1" dirty="0">
-                <a:solidFill>
-                  <a:srgbClr val="0D1540"/>
-                </a:solidFill>
-                <a:latin typeface="Segoe UI"/>
-              </a:rPr>
-              <a:t>“</a:t>
-            </a:r>
-            <a:r>
-              <a:rPr lang="de-DE" sz="1400" b="1" dirty="0">
-                <a:solidFill>
-                  <a:srgbClr val="0D1540"/>
-                </a:solidFill>
-                <a:latin typeface="Segoe UI"/>
-              </a:rPr>
-              <a:t>Kenneth</a:t>
-            </a:r>
-            <a:r>
-              <a:rPr sz="1400" b="1" dirty="0">
-                <a:solidFill>
-                  <a:srgbClr val="0D1540"/>
-                </a:solidFill>
-                <a:latin typeface="Segoe UI"/>
-              </a:rPr>
-              <a:t> never wrote a line of code</a:t>
-            </a:r>
-            <a:r>
-              <a:rPr lang="de-DE" sz="1400" b="1" dirty="0">
-                <a:solidFill>
-                  <a:srgbClr val="0D1540"/>
-                </a:solidFill>
-                <a:latin typeface="Segoe UI"/>
-              </a:rPr>
-              <a:t>, AI </a:t>
-            </a:r>
-            <a:r>
-              <a:rPr lang="de-DE" sz="1400" b="1" dirty="0" err="1">
-                <a:solidFill>
-                  <a:srgbClr val="0D1540"/>
-                </a:solidFill>
-                <a:latin typeface="Segoe UI"/>
-              </a:rPr>
-              <a:t>did</a:t>
-            </a:r>
-            <a:r>
-              <a:rPr sz="1400" b="1" dirty="0">
-                <a:solidFill>
-                  <a:srgbClr val="0D1540"/>
-                </a:solidFill>
-                <a:latin typeface="Segoe UI"/>
-              </a:rPr>
-              <a:t>. AI never made a product decision</a:t>
-            </a:r>
-            <a:r>
-              <a:rPr lang="de-DE" sz="1400" b="1" dirty="0">
-                <a:solidFill>
-                  <a:srgbClr val="0D1540"/>
-                </a:solidFill>
-                <a:latin typeface="Segoe UI"/>
-              </a:rPr>
-              <a:t>, Kenneth </a:t>
-            </a:r>
-            <a:r>
-              <a:rPr lang="de-DE" sz="1400" b="1" dirty="0" err="1">
-                <a:solidFill>
-                  <a:srgbClr val="0D1540"/>
-                </a:solidFill>
-                <a:latin typeface="Segoe UI"/>
-              </a:rPr>
-              <a:t>did</a:t>
-            </a:r>
-            <a:r>
-              <a:rPr sz="1400" b="1" dirty="0">
-                <a:solidFill>
-                  <a:srgbClr val="0D1540"/>
-                </a:solidFill>
-                <a:latin typeface="Segoe UI"/>
-              </a:rPr>
-              <a:t>.
-Each played to their strengths.  65,700 lines.  299 files.  4 months.  One </a:t>
-            </a:r>
-            <a:r>
-              <a:rPr lang="de-DE" sz="1400" b="1" dirty="0">
-                <a:solidFill>
-                  <a:srgbClr val="0D1540"/>
-                </a:solidFill>
-                <a:latin typeface="Segoe UI"/>
-              </a:rPr>
-              <a:t>human </a:t>
-            </a:r>
-            <a:r>
-              <a:rPr lang="de-DE" sz="1400" b="1" dirty="0" err="1">
-                <a:solidFill>
-                  <a:srgbClr val="0D1540"/>
-                </a:solidFill>
-                <a:latin typeface="Segoe UI"/>
-              </a:rPr>
-              <a:t>involved</a:t>
-            </a:r>
-            <a:r>
-              <a:rPr sz="1400" b="1" dirty="0">
-                <a:solidFill>
-                  <a:srgbClr val="0D1540"/>
-                </a:solidFill>
-                <a:latin typeface="Segoe UI"/>
-              </a:rPr>
-              <a:t>.”</a:t>
-            </a:r>
-          </a:p>
-        </p:txBody>
-      </p:sp>
-    </p:spTree>
-  </p:cSld>
-  <p:clrMapOvr>
-    <a:masterClrMapping/>
-  </p:clrMapOvr>
-</p:sld>
-</file>
-
-<file path=ppt/slides/slide25.xml><?xml version="1.0" encoding="utf-8"?>
-<p:sld xmlns:a="http://schemas.openxmlformats.org/drawingml/2006/main" xmlns:r="http://schemas.openxmlformats.org/officeDocument/2006/relationships" xmlns:p="http://schemas.openxmlformats.org/presentationml/2006/main">
-  <p:cSld>
-    <p:bg>
-      <p:bgPr>
-        <a:solidFill>
-          <a:srgbClr val="0F172A"/>
-        </a:solidFill>
-        <a:effectLst/>
-      </p:bgPr>
-    </p:bg>
-    <p:spTree>
-      <p:nvGrpSpPr>
-        <p:cNvPr id="1" name=""/>
-        <p:cNvGrpSpPr/>
-        <p:nvPr/>
-      </p:nvGrpSpPr>
-      <p:grpSpPr>
-        <a:xfrm>
-          <a:off x="0" y="0"/>
-          <a:ext cx="0" cy="0"/>
-          <a:chOff x="0" y="0"/>
-          <a:chExt cx="0" cy="0"/>
-        </a:xfrm>
-      </p:grpSpPr>
-      <p:sp>
-        <p:nvSpPr>
-          <p:cNvPr id="2" name="Rectangle 1"/>
-          <p:cNvSpPr/>
-          <p:nvPr/>
-        </p:nvSpPr>
-        <p:spPr>
-          <a:xfrm>
-            <a:off x="0" y="0"/>
-            <a:ext cx="12191695" cy="6858000"/>
-          </a:xfrm>
-          <a:prstGeom prst="rect">
-            <a:avLst/>
-          </a:prstGeom>
-          <a:solidFill>
-            <a:srgbClr val="0F172A"/>
-          </a:solidFill>
-          <a:ln>
-            <a:noFill/>
-          </a:ln>
-        </p:spPr>
-        <p:style>
-          <a:lnRef idx="1">
-            <a:schemeClr val="accent1"/>
-          </a:lnRef>
-          <a:fillRef idx="3">
-            <a:schemeClr val="accent1"/>
-          </a:fillRef>
-          <a:effectRef idx="2">
-            <a:schemeClr val="accent1"/>
-          </a:effectRef>
-          <a:fontRef idx="minor">
-            <a:schemeClr val="lt1"/>
-          </a:fontRef>
-        </p:style>
-        <p:txBody>
-          <a:bodyPr rtlCol="0" anchor="ctr"/>
-          <a:lstStyle/>
-          <a:p>
-            <a:pPr algn="ctr"/>
-            <a:endParaRPr/>
-          </a:p>
-        </p:txBody>
-      </p:sp>
-      <p:sp>
-        <p:nvSpPr>
-          <p:cNvPr id="3" name="Rectangle 2"/>
-          <p:cNvSpPr/>
-          <p:nvPr/>
-        </p:nvSpPr>
-        <p:spPr>
-          <a:xfrm>
-            <a:off x="822960" y="914400"/>
-            <a:ext cx="137160" cy="5029200"/>
-          </a:xfrm>
-          <a:prstGeom prst="rect">
-            <a:avLst/>
-          </a:prstGeom>
-          <a:solidFill>
-            <a:srgbClr val="3069F0"/>
-          </a:solidFill>
-          <a:ln>
-            <a:noFill/>
-          </a:ln>
-        </p:spPr>
-        <p:style>
-          <a:lnRef idx="1">
-            <a:schemeClr val="accent1"/>
-          </a:lnRef>
-          <a:fillRef idx="3">
-            <a:schemeClr val="accent1"/>
-          </a:fillRef>
-          <a:effectRef idx="2">
-            <a:schemeClr val="accent1"/>
-          </a:effectRef>
-          <a:fontRef idx="minor">
-            <a:schemeClr val="lt1"/>
-          </a:fontRef>
-        </p:style>
-        <p:txBody>
-          <a:bodyPr rtlCol="0" anchor="ctr"/>
-          <a:lstStyle/>
-          <a:p>
-            <a:pPr algn="ctr"/>
-            <a:endParaRPr/>
-          </a:p>
-        </p:txBody>
-      </p:sp>
-      <p:sp>
-        <p:nvSpPr>
-          <p:cNvPr id="4" name="TextBox 3"/>
-          <p:cNvSpPr txBox="1"/>
-          <p:nvPr/>
-        </p:nvSpPr>
-        <p:spPr>
-          <a:xfrm>
-            <a:off x="1188720" y="1097280"/>
-            <a:ext cx="9601200" cy="1097280"/>
-          </a:xfrm>
-          <a:prstGeom prst="rect">
-            <a:avLst/>
-          </a:prstGeom>
-          <a:noFill/>
-        </p:spPr>
-        <p:txBody>
-          <a:bodyPr wrap="none">
-            <a:spAutoFit/>
-          </a:bodyPr>
-          <a:lstStyle/>
-          <a:p>
-            <a:pPr>
-              <a:defRPr sz="4400" b="1">
-                <a:solidFill>
-                  <a:srgbClr val="F1F5F9"/>
-                </a:solidFill>
-              </a:defRPr>
-            </a:pPr>
-            <a:r>
-              <a:t>Under the Hood, It's All Evidence</a:t>
-            </a:r>
-          </a:p>
-        </p:txBody>
-      </p:sp>
-      <p:sp>
-        <p:nvSpPr>
-          <p:cNvPr id="5" name="TextBox 4"/>
-          <p:cNvSpPr txBox="1"/>
-          <p:nvPr/>
-        </p:nvSpPr>
-        <p:spPr>
-          <a:xfrm>
-            <a:off x="1188720" y="2286000"/>
-            <a:ext cx="9144000" cy="548640"/>
-          </a:xfrm>
-          <a:prstGeom prst="rect">
-            <a:avLst/>
-          </a:prstGeom>
-          <a:noFill/>
-        </p:spPr>
-        <p:txBody>
-          <a:bodyPr wrap="square">
-            <a:spAutoFit/>
-          </a:bodyPr>
-          <a:lstStyle/>
-          <a:p>
-            <a:pPr>
-              <a:defRPr sz="1800">
-                <a:solidFill>
-                  <a:srgbClr val="94A3B8"/>
-                </a:solidFill>
-              </a:defRPr>
-            </a:pPr>
-            <a:r>
-              <a:t>MIP doesn't predict the market. It measures what works, earns trust through evidence, and only acts when the math supports it.</a:t>
-            </a:r>
-          </a:p>
-        </p:txBody>
-      </p:sp>
-      <p:sp>
-        <p:nvSpPr>
-          <p:cNvPr id="6" name="Rectangle 5"/>
-          <p:cNvSpPr/>
-          <p:nvPr/>
-        </p:nvSpPr>
-        <p:spPr>
-          <a:xfrm>
-            <a:off x="1188720" y="3017520"/>
-            <a:ext cx="3657600" cy="36576"/>
-          </a:xfrm>
-          <a:prstGeom prst="rect">
-            <a:avLst/>
-          </a:prstGeom>
-          <a:solidFill>
-            <a:srgbClr val="3069F0"/>
-          </a:solidFill>
-          <a:ln>
-            <a:noFill/>
-          </a:ln>
-        </p:spPr>
-        <p:style>
-          <a:lnRef idx="1">
-            <a:schemeClr val="accent1"/>
-          </a:lnRef>
-          <a:fillRef idx="3">
-            <a:schemeClr val="accent1"/>
-          </a:fillRef>
-          <a:effectRef idx="2">
-            <a:schemeClr val="accent1"/>
-          </a:effectRef>
-          <a:fontRef idx="minor">
-            <a:schemeClr val="lt1"/>
-          </a:fontRef>
-        </p:style>
-        <p:txBody>
-          <a:bodyPr rtlCol="0" anchor="ctr"/>
-          <a:lstStyle/>
-          <a:p>
-            <a:pPr algn="ctr"/>
-            <a:endParaRPr/>
-          </a:p>
-        </p:txBody>
-      </p:sp>
-      <p:sp>
-        <p:nvSpPr>
-          <p:cNvPr id="7" name="TextBox 6"/>
-          <p:cNvSpPr txBox="1"/>
-          <p:nvPr/>
-        </p:nvSpPr>
-        <p:spPr>
-          <a:xfrm>
-            <a:off x="1188720" y="3246120"/>
-            <a:ext cx="9144000" cy="384048"/>
-          </a:xfrm>
-          <a:prstGeom prst="rect">
-            <a:avLst/>
-          </a:prstGeom>
-          <a:noFill/>
-        </p:spPr>
-        <p:txBody>
-          <a:bodyPr wrap="square">
-            <a:spAutoFit/>
-          </a:bodyPr>
-          <a:lstStyle/>
-          <a:p>
-            <a:pPr>
-              <a:defRPr sz="1500">
-                <a:solidFill>
-                  <a:srgbClr val="CBD5E1"/>
-                </a:solidFill>
-              </a:defRPr>
-            </a:pPr>
-            <a:r>
-              <a:t>🚨  Signals  —  Patterns fire based on math, not intuition</a:t>
-            </a:r>
-          </a:p>
-        </p:txBody>
-      </p:sp>
-      <p:sp>
-        <p:nvSpPr>
-          <p:cNvPr id="8" name="TextBox 7"/>
-          <p:cNvSpPr txBox="1"/>
-          <p:nvPr/>
-        </p:nvSpPr>
-        <p:spPr>
-          <a:xfrm>
-            <a:off x="1188720" y="3675887"/>
-            <a:ext cx="9144000" cy="384048"/>
-          </a:xfrm>
-          <a:prstGeom prst="rect">
-            <a:avLst/>
-          </a:prstGeom>
-          <a:noFill/>
-        </p:spPr>
-        <p:txBody>
-          <a:bodyPr wrap="square">
-            <a:spAutoFit/>
-          </a:bodyPr>
-          <a:lstStyle/>
-          <a:p>
-            <a:pPr>
-              <a:defRPr sz="1500">
-                <a:solidFill>
-                  <a:srgbClr val="CBD5E1"/>
-                </a:solidFill>
-              </a:defRPr>
-            </a:pPr>
-            <a:r>
-              <a:t>🎓  Training  —  Maturity is earned through evidence, not declared</a:t>
-            </a:r>
-          </a:p>
-        </p:txBody>
-      </p:sp>
-      <p:sp>
-        <p:nvSpPr>
-          <p:cNvPr id="9" name="TextBox 8"/>
-          <p:cNvSpPr txBox="1"/>
-          <p:nvPr/>
-        </p:nvSpPr>
-        <p:spPr>
-          <a:xfrm>
-            <a:off x="1188720" y="4105655"/>
-            <a:ext cx="9144000" cy="384048"/>
-          </a:xfrm>
-          <a:prstGeom prst="rect">
-            <a:avLst/>
-          </a:prstGeom>
-          <a:noFill/>
-        </p:spPr>
-        <p:txBody>
-          <a:bodyPr wrap="square">
-            <a:spAutoFit/>
-          </a:bodyPr>
-          <a:lstStyle/>
-          <a:p>
-            <a:pPr>
-              <a:defRPr sz="1500">
-                <a:solidFill>
-                  <a:srgbClr val="CBD5E1"/>
-                </a:solidFill>
-              </a:defRPr>
-            </a:pPr>
-            <a:r>
-              <a:t>🚧  Gates  —  5 independent checks must ALL pass before execution</a:t>
-            </a:r>
-          </a:p>
-        </p:txBody>
-      </p:sp>
-      <p:sp>
-        <p:nvSpPr>
-          <p:cNvPr id="10" name="TextBox 9"/>
-          <p:cNvSpPr txBox="1"/>
-          <p:nvPr/>
-        </p:nvSpPr>
-        <p:spPr>
-          <a:xfrm>
-            <a:off x="1188720" y="4535423"/>
-            <a:ext cx="9144000" cy="384048"/>
-          </a:xfrm>
-          <a:prstGeom prst="rect">
-            <a:avLst/>
-          </a:prstGeom>
-          <a:noFill/>
-        </p:spPr>
-        <p:txBody>
-          <a:bodyPr wrap="square">
-            <a:spAutoFit/>
-          </a:bodyPr>
-          <a:lstStyle/>
-          <a:p>
-            <a:pPr>
-              <a:defRPr sz="1500">
-                <a:solidFill>
-                  <a:srgbClr val="CBD5E1"/>
-                </a:solidFill>
-              </a:defRPr>
-            </a:pPr>
-            <a:r>
-              <a:t>📊  Sizing  —  Position size is calculated, never guessed</a:t>
-            </a:r>
-          </a:p>
-        </p:txBody>
-      </p:sp>
-      <p:sp>
-        <p:nvSpPr>
-          <p:cNvPr id="11" name="TextBox 10"/>
-          <p:cNvSpPr txBox="1"/>
-          <p:nvPr/>
-        </p:nvSpPr>
-        <p:spPr>
-          <a:xfrm>
-            <a:off x="1188720" y="4965191"/>
-            <a:ext cx="9144000" cy="384048"/>
-          </a:xfrm>
-          <a:prstGeom prst="rect">
-            <a:avLst/>
-          </a:prstGeom>
-          <a:noFill/>
-        </p:spPr>
-        <p:txBody>
-          <a:bodyPr wrap="square">
-            <a:spAutoFit/>
-          </a:bodyPr>
-          <a:lstStyle/>
-          <a:p>
-            <a:pPr>
-              <a:defRPr sz="1500">
-                <a:solidFill>
-                  <a:srgbClr val="CBD5E1"/>
-                </a:solidFill>
-              </a:defRPr>
-            </a:pPr>
-            <a:r>
-              <a:t>📰  News  —  Influence is bounded — headlines can't override gates</a:t>
-            </a:r>
-          </a:p>
-        </p:txBody>
-      </p:sp>
-      <p:sp>
-        <p:nvSpPr>
-          <p:cNvPr id="12" name="TextBox 11"/>
-          <p:cNvSpPr txBox="1"/>
-          <p:nvPr/>
-        </p:nvSpPr>
-        <p:spPr>
-          <a:xfrm>
-            <a:off x="1188720" y="5394959"/>
-            <a:ext cx="9144000" cy="384048"/>
-          </a:xfrm>
-          <a:prstGeom prst="rect">
-            <a:avLst/>
-          </a:prstGeom>
-          <a:noFill/>
-        </p:spPr>
-        <p:txBody>
-          <a:bodyPr wrap="square">
-            <a:spAutoFit/>
-          </a:bodyPr>
-          <a:lstStyle/>
-          <a:p>
-            <a:pPr>
-              <a:defRPr sz="1500">
-                <a:solidFill>
-                  <a:srgbClr val="CBD5E1"/>
-                </a:solidFill>
-              </a:defRPr>
-            </a:pPr>
-            <a:r>
-              <a:t>🌍  Parallel Worlds  —  Every strategy is stress-tested against alternatives</a:t>
-            </a:r>
-          </a:p>
-        </p:txBody>
-      </p:sp>
-      <p:sp>
-        <p:nvSpPr>
-          <p:cNvPr id="13" name="TextBox 12"/>
-          <p:cNvSpPr txBox="1"/>
-          <p:nvPr/>
-        </p:nvSpPr>
-        <p:spPr>
-          <a:xfrm>
-            <a:off x="1188720" y="5824727"/>
-            <a:ext cx="9144000" cy="384048"/>
-          </a:xfrm>
-          <a:prstGeom prst="rect">
-            <a:avLst/>
-          </a:prstGeom>
-          <a:noFill/>
-        </p:spPr>
-        <p:txBody>
-          <a:bodyPr wrap="square">
-            <a:spAutoFit/>
-          </a:bodyPr>
-          <a:lstStyle/>
-          <a:p>
-            <a:pPr>
-              <a:defRPr sz="1500">
-                <a:solidFill>
-                  <a:srgbClr val="CBD5E1"/>
-                </a:solidFill>
-              </a:defRPr>
-            </a:pPr>
-            <a:r>
-              <a:t>🔄  Learning  —  Every outcome updates the system's knowledge</a:t>
             </a:r>
           </a:p>
         </p:txBody>

</xml_diff>

<commit_message>
chore: update MIP presentation file
- Updated the 'MIP how does it work.pptx' presentation to reflect recent changes and improvements in the project.
</commit_message>
<xml_diff>
--- a/docs/MIP how does it work.pptx
+++ b/docs/MIP how does it work.pptx
@@ -147,30 +147,15 @@
 </p:presentation>
 </file>
 
-<file path=ppt/revisionInfo.xml><?xml version="1.0" encoding="utf-8"?>
-<p1510:revInfo xmlns:a="http://schemas.openxmlformats.org/drawingml/2006/main" xmlns:r="http://schemas.openxmlformats.org/officeDocument/2006/relationships" xmlns:p1510="http://schemas.microsoft.com/office/powerpoint/2015/10/main">
-  <p1510:revLst>
-    <p1510:client id="{D71A922C-2E0C-48D8-906C-43BE0B894A6A}" v="10" dt="2026-03-20T08:50:35.928"/>
-  </p1510:revLst>
-</p1510:revInfo>
-</file>
-
 <file path=ppt/changesInfos/changesInfo1.xml><?xml version="1.0" encoding="utf-8"?>
 <pc:chgInfo xmlns:a="http://schemas.openxmlformats.org/drawingml/2006/main" xmlns:r="http://schemas.openxmlformats.org/officeDocument/2006/relationships" xmlns:ac="http://schemas.microsoft.com/office/drawing/2013/main/command" xmlns:pc="http://schemas.microsoft.com/office/powerpoint/2013/main/command">
   <pc:docChgLst>
     <pc:chgData name="Kenneth Jebjerg" userId="31b26a954995a5e4" providerId="LiveId" clId="{FB9E2242-EB45-4C40-9CD8-7B1EDA37FE0A}"/>
     <pc:docChg chg="undo custSel addSld delSld modSld sldOrd">
-      <pc:chgData name="Kenneth Jebjerg" userId="31b26a954995a5e4" providerId="LiveId" clId="{FB9E2242-EB45-4C40-9CD8-7B1EDA37FE0A}" dt="2026-03-20T10:20:55.555" v="348" actId="6549"/>
+      <pc:chgData name="Kenneth Jebjerg" userId="31b26a954995a5e4" providerId="LiveId" clId="{FB9E2242-EB45-4C40-9CD8-7B1EDA37FE0A}" dt="2026-04-04T12:04:53.176" v="382" actId="20577"/>
       <pc:docMkLst>
         <pc:docMk/>
       </pc:docMkLst>
-      <pc:sldChg chg="del">
-        <pc:chgData name="Kenneth Jebjerg" userId="31b26a954995a5e4" providerId="LiveId" clId="{FB9E2242-EB45-4C40-9CD8-7B1EDA37FE0A}" dt="2026-03-20T08:54:31.258" v="76" actId="47"/>
-        <pc:sldMkLst>
-          <pc:docMk/>
-          <pc:sldMk cId="0" sldId="256"/>
-        </pc:sldMkLst>
-      </pc:sldChg>
       <pc:sldChg chg="modSp mod">
         <pc:chgData name="Kenneth Jebjerg" userId="31b26a954995a5e4" providerId="LiveId" clId="{FB9E2242-EB45-4C40-9CD8-7B1EDA37FE0A}" dt="2026-03-20T08:54:53.765" v="79" actId="167"/>
         <pc:sldMkLst>
@@ -185,20 +170,6 @@
             <ac:spMk id="2" creationId="{00000000-0000-0000-0000-000000000000}"/>
           </ac:spMkLst>
         </pc:spChg>
-      </pc:sldChg>
-      <pc:sldChg chg="del">
-        <pc:chgData name="Kenneth Jebjerg" userId="31b26a954995a5e4" providerId="LiveId" clId="{FB9E2242-EB45-4C40-9CD8-7B1EDA37FE0A}" dt="2026-03-20T08:24:59.413" v="0" actId="47"/>
-        <pc:sldMkLst>
-          <pc:docMk/>
-          <pc:sldMk cId="0" sldId="258"/>
-        </pc:sldMkLst>
-      </pc:sldChg>
-      <pc:sldChg chg="del">
-        <pc:chgData name="Kenneth Jebjerg" userId="31b26a954995a5e4" providerId="LiveId" clId="{FB9E2242-EB45-4C40-9CD8-7B1EDA37FE0A}" dt="2026-03-20T08:41:08.870" v="25" actId="47"/>
-        <pc:sldMkLst>
-          <pc:docMk/>
-          <pc:sldMk cId="0" sldId="264"/>
-        </pc:sldMkLst>
       </pc:sldChg>
       <pc:sldChg chg="ord">
         <pc:chgData name="Kenneth Jebjerg" userId="31b26a954995a5e4" providerId="LiveId" clId="{FB9E2242-EB45-4C40-9CD8-7B1EDA37FE0A}" dt="2026-03-20T08:27:15.029" v="2"/>
@@ -316,13 +287,6 @@
           </ac:spMkLst>
         </pc:spChg>
       </pc:sldChg>
-      <pc:sldChg chg="add del setBg">
-        <pc:chgData name="Kenneth Jebjerg" userId="31b26a954995a5e4" providerId="LiveId" clId="{FB9E2242-EB45-4C40-9CD8-7B1EDA37FE0A}" dt="2026-03-20T08:49:31.781" v="36" actId="2696"/>
-        <pc:sldMkLst>
-          <pc:docMk/>
-          <pc:sldMk cId="0" sldId="269"/>
-        </pc:sldMkLst>
-      </pc:sldChg>
       <pc:sldChg chg="modSp add mod">
         <pc:chgData name="Kenneth Jebjerg" userId="31b26a954995a5e4" providerId="LiveId" clId="{FB9E2242-EB45-4C40-9CD8-7B1EDA37FE0A}" dt="2026-03-20T09:09:08.630" v="130" actId="12"/>
         <pc:sldMkLst>
@@ -354,13 +318,6 @@
           </ac:spMkLst>
         </pc:spChg>
       </pc:sldChg>
-      <pc:sldChg chg="del">
-        <pc:chgData name="Kenneth Jebjerg" userId="31b26a954995a5e4" providerId="LiveId" clId="{FB9E2242-EB45-4C40-9CD8-7B1EDA37FE0A}" dt="2026-03-20T10:13:15.135" v="131" actId="47"/>
-        <pc:sldMkLst>
-          <pc:docMk/>
-          <pc:sldMk cId="0" sldId="270"/>
-        </pc:sldMkLst>
-      </pc:sldChg>
       <pc:sldChg chg="add setBg">
         <pc:chgData name="Kenneth Jebjerg" userId="31b26a954995a5e4" providerId="LiveId" clId="{FB9E2242-EB45-4C40-9CD8-7B1EDA37FE0A}" dt="2026-03-20T08:37:03.007" v="8"/>
         <pc:sldMkLst>
@@ -375,13 +332,6 @@
           <pc:sldMk cId="0" sldId="273"/>
         </pc:sldMkLst>
       </pc:sldChg>
-      <pc:sldChg chg="add del setBg">
-        <pc:chgData name="Kenneth Jebjerg" userId="31b26a954995a5e4" providerId="LiveId" clId="{FB9E2242-EB45-4C40-9CD8-7B1EDA37FE0A}" dt="2026-03-20T10:13:15.135" v="131" actId="47"/>
-        <pc:sldMkLst>
-          <pc:docMk/>
-          <pc:sldMk cId="0" sldId="274"/>
-        </pc:sldMkLst>
-      </pc:sldChg>
       <pc:sldChg chg="add setBg">
         <pc:chgData name="Kenneth Jebjerg" userId="31b26a954995a5e4" providerId="LiveId" clId="{FB9E2242-EB45-4C40-9CD8-7B1EDA37FE0A}" dt="2026-03-20T08:41:31.425" v="26"/>
         <pc:sldMkLst>
@@ -394,13 +344,6 @@
         <pc:sldMkLst>
           <pc:docMk/>
           <pc:sldMk cId="0" sldId="276"/>
-        </pc:sldMkLst>
-      </pc:sldChg>
-      <pc:sldChg chg="add del setBg">
-        <pc:chgData name="Kenneth Jebjerg" userId="31b26a954995a5e4" providerId="LiveId" clId="{FB9E2242-EB45-4C40-9CD8-7B1EDA37FE0A}" dt="2026-03-20T10:13:15.135" v="131" actId="47"/>
-        <pc:sldMkLst>
-          <pc:docMk/>
-          <pc:sldMk cId="0" sldId="277"/>
         </pc:sldMkLst>
       </pc:sldChg>
       <pc:sldChg chg="add setBg">
@@ -583,12 +526,20 @@
           </ac:spMkLst>
         </pc:spChg>
       </pc:sldChg>
-      <pc:sldChg chg="add setBg">
-        <pc:chgData name="Kenneth Jebjerg" userId="31b26a954995a5e4" providerId="LiveId" clId="{FB9E2242-EB45-4C40-9CD8-7B1EDA37FE0A}" dt="2026-03-20T08:47:53.026" v="33"/>
+      <pc:sldChg chg="modSp add mod setBg">
+        <pc:chgData name="Kenneth Jebjerg" userId="31b26a954995a5e4" providerId="LiveId" clId="{FB9E2242-EB45-4C40-9CD8-7B1EDA37FE0A}" dt="2026-04-04T12:04:53.176" v="382" actId="20577"/>
         <pc:sldMkLst>
           <pc:docMk/>
           <pc:sldMk cId="0" sldId="282"/>
         </pc:sldMkLst>
+        <pc:spChg chg="mod">
+          <ac:chgData name="Kenneth Jebjerg" userId="31b26a954995a5e4" providerId="LiveId" clId="{FB9E2242-EB45-4C40-9CD8-7B1EDA37FE0A}" dt="2026-04-04T12:04:53.176" v="382" actId="20577"/>
+          <ac:spMkLst>
+            <pc:docMk/>
+            <pc:sldMk cId="0" sldId="282"/>
+            <ac:spMk id="67" creationId="{00000000-0000-0000-0000-000000000000}"/>
+          </ac:spMkLst>
+        </pc:spChg>
       </pc:sldChg>
       <pc:sldChg chg="addSp delSp modSp add del mod setBg">
         <pc:chgData name="Kenneth Jebjerg" userId="31b26a954995a5e4" providerId="LiveId" clId="{FB9E2242-EB45-4C40-9CD8-7B1EDA37FE0A}" dt="2026-03-20T09:03:30.604" v="85" actId="1076"/>
@@ -700,7 +651,7 @@
           <a:p>
             <a:fld id="{523F5B02-391E-4F5F-BD0B-5889F5D3F792}" type="datetimeFigureOut">
               <a:rPr lang="LID4096" smtClean="0"/>
-              <a:t>03/20/2026</a:t>
+              <a:t>04/04/2026</a:t>
             </a:fld>
             <a:endParaRPr lang="LID4096"/>
           </a:p>
@@ -1147,7 +1098,7 @@
           <a:p>
             <a:fld id="{5BCAD085-E8A6-8845-BD4E-CB4CCA059FC4}" type="datetimeFigureOut">
               <a:rPr lang="en-US" smtClean="0"/>
-              <a:t>3/20/2026</a:t>
+              <a:t>4/4/2026</a:t>
             </a:fld>
             <a:endParaRPr lang="en-US"/>
           </a:p>
@@ -1315,7 +1266,7 @@
           <a:p>
             <a:fld id="{5BCAD085-E8A6-8845-BD4E-CB4CCA059FC4}" type="datetimeFigureOut">
               <a:rPr lang="en-US" smtClean="0"/>
-              <a:t>3/20/2026</a:t>
+              <a:t>4/4/2026</a:t>
             </a:fld>
             <a:endParaRPr lang="en-US"/>
           </a:p>
@@ -1493,7 +1444,7 @@
           <a:p>
             <a:fld id="{5BCAD085-E8A6-8845-BD4E-CB4CCA059FC4}" type="datetimeFigureOut">
               <a:rPr lang="en-US" smtClean="0"/>
-              <a:t>3/20/2026</a:t>
+              <a:t>4/4/2026</a:t>
             </a:fld>
             <a:endParaRPr lang="en-US"/>
           </a:p>
@@ -1661,7 +1612,7 @@
           <a:p>
             <a:fld id="{5BCAD085-E8A6-8845-BD4E-CB4CCA059FC4}" type="datetimeFigureOut">
               <a:rPr lang="en-US" smtClean="0"/>
-              <a:t>3/20/2026</a:t>
+              <a:t>4/4/2026</a:t>
             </a:fld>
             <a:endParaRPr lang="en-US"/>
           </a:p>
@@ -1906,7 +1857,7 @@
           <a:p>
             <a:fld id="{5BCAD085-E8A6-8845-BD4E-CB4CCA059FC4}" type="datetimeFigureOut">
               <a:rPr lang="en-US" smtClean="0"/>
-              <a:t>3/20/2026</a:t>
+              <a:t>4/4/2026</a:t>
             </a:fld>
             <a:endParaRPr lang="en-US"/>
           </a:p>
@@ -2191,7 +2142,7 @@
           <a:p>
             <a:fld id="{5BCAD085-E8A6-8845-BD4E-CB4CCA059FC4}" type="datetimeFigureOut">
               <a:rPr lang="en-US" smtClean="0"/>
-              <a:t>3/20/2026</a:t>
+              <a:t>4/4/2026</a:t>
             </a:fld>
             <a:endParaRPr lang="en-US"/>
           </a:p>
@@ -2610,7 +2561,7 @@
           <a:p>
             <a:fld id="{5BCAD085-E8A6-8845-BD4E-CB4CCA059FC4}" type="datetimeFigureOut">
               <a:rPr lang="en-US" smtClean="0"/>
-              <a:t>3/20/2026</a:t>
+              <a:t>4/4/2026</a:t>
             </a:fld>
             <a:endParaRPr lang="en-US"/>
           </a:p>
@@ -2727,7 +2678,7 @@
           <a:p>
             <a:fld id="{5BCAD085-E8A6-8845-BD4E-CB4CCA059FC4}" type="datetimeFigureOut">
               <a:rPr lang="en-US" smtClean="0"/>
-              <a:t>3/20/2026</a:t>
+              <a:t>4/4/2026</a:t>
             </a:fld>
             <a:endParaRPr lang="en-US"/>
           </a:p>
@@ -2822,7 +2773,7 @@
           <a:p>
             <a:fld id="{5BCAD085-E8A6-8845-BD4E-CB4CCA059FC4}" type="datetimeFigureOut">
               <a:rPr lang="en-US" smtClean="0"/>
-              <a:t>3/20/2026</a:t>
+              <a:t>4/4/2026</a:t>
             </a:fld>
             <a:endParaRPr lang="en-US"/>
           </a:p>
@@ -3097,7 +3048,7 @@
           <a:p>
             <a:fld id="{5BCAD085-E8A6-8845-BD4E-CB4CCA059FC4}" type="datetimeFigureOut">
               <a:rPr lang="en-US" smtClean="0"/>
-              <a:t>3/20/2026</a:t>
+              <a:t>4/4/2026</a:t>
             </a:fld>
             <a:endParaRPr lang="en-US"/>
           </a:p>
@@ -3349,7 +3300,7 @@
           <a:p>
             <a:fld id="{5BCAD085-E8A6-8845-BD4E-CB4CCA059FC4}" type="datetimeFigureOut">
               <a:rPr lang="en-US" smtClean="0"/>
-              <a:t>3/20/2026</a:t>
+              <a:t>4/4/2026</a:t>
             </a:fld>
             <a:endParaRPr lang="en-US"/>
           </a:p>
@@ -3560,7 +3511,7 @@
           <a:p>
             <a:fld id="{5BCAD085-E8A6-8845-BD4E-CB4CCA059FC4}" type="datetimeFigureOut">
               <a:rPr lang="en-US" smtClean="0"/>
-              <a:t>3/20/2026</a:t>
+              <a:t>4/4/2026</a:t>
             </a:fld>
             <a:endParaRPr lang="en-US"/>
           </a:p>
@@ -25539,7 +25490,7 @@
         <p:spPr>
           <a:xfrm>
             <a:off x="914400" y="5833872"/>
-            <a:ext cx="10424160" cy="731520"/>
+            <a:ext cx="10424160" cy="523220"/>
           </a:xfrm>
           <a:prstGeom prst="rect">
             <a:avLst/>
@@ -25560,6 +25511,7 @@
               </a:defRPr>
             </a:pPr>
             <a:r>
+              <a:rPr dirty="0"/>
               <a:t>“Kenneth never wrote a line of code, AI did.  AI never made a product decision, Kenneth did.</a:t>
             </a:r>
           </a:p>
@@ -25572,7 +25524,24 @@
               </a:defRPr>
             </a:pPr>
             <a:r>
-              <a:t>Each played to their strengths.  117,700 lines.  594 files.  6 months.  One human involved.”</a:t>
+              <a:rPr dirty="0"/>
+              <a:t>Each played to their strengths.  117,700 lines.  594 files.  6 months.  One human involved</a:t>
+            </a:r>
+            <a:r>
+              <a:rPr lang="de-DE" dirty="0"/>
+              <a:t> (spare time after </a:t>
+            </a:r>
+            <a:r>
+              <a:rPr lang="de-DE" dirty="0" err="1"/>
+              <a:t>work</a:t>
+            </a:r>
+            <a:r>
+              <a:rPr lang="de-DE" dirty="0"/>
+              <a:t>)</a:t>
+            </a:r>
+            <a:r>
+              <a:rPr dirty="0"/>
+              <a:t>.”</a:t>
             </a:r>
           </a:p>
         </p:txBody>

</xml_diff>